<commit_message>
V5 deck: walkthrough panels show the standard fields; line-break sweep; uniform diagram borders
The collection, items and single-feature panels now show the full standard
responses (collection crs/extent/links; feature crs/trs/bbox/time/geometry/
links) consistent with the backing-model slide and the server. Reflows the CRS
object and widens the single-feature panel so no line wraps. The slide-2 tier
diagram uses one border width and corner radius across the client, API and
database boxes.
</commit_message>
<xml_diff>
--- a/MobilityAPIV5.pptx
+++ b/MobilityAPIV5.pptx
@@ -8213,7 +8213,7 @@
         <p:spPr>
           <a:xfrm>
             <a:off x="6281928" y="2194560"/>
-            <a:ext cx="5342839" cy="2103120"/>
+            <a:ext cx="5342839" cy="2743200"/>
           </a:xfrm>
           <a:prstGeom prst="roundRect">
             <a:avLst>
@@ -8259,7 +8259,7 @@
         <p:spPr>
           <a:xfrm>
             <a:off x="6409944" y="2286000"/>
-            <a:ext cx="5086807" cy="1920239"/>
+            <a:ext cx="5086807" cy="2560320"/>
           </a:xfrm>
           <a:prstGeom prst="rect">
             <a:avLst/>
@@ -8348,6 +8348,42 @@
                 </a:solidFill>
                 <a:latin typeface="Consolas"/>
               </a:rPr>
+              <a:t>, </a:t>
+            </a:r>
+            <a:r>
+              <a:rPr sz="1200">
+                <a:solidFill>
+                  <a:srgbClr val="6FC3E0"/>
+                </a:solidFill>
+                <a:latin typeface="Consolas"/>
+              </a:rPr>
+              <a:t>"title"</a:t>
+            </a:r>
+            <a:r>
+              <a:rPr sz="1200">
+                <a:solidFill>
+                  <a:srgbClr val="C2D0DA"/>
+                </a:solidFill>
+                <a:latin typeface="Consolas"/>
+              </a:rPr>
+              <a:t>: </a:t>
+            </a:r>
+            <a:r>
+              <a:rPr sz="1200">
+                <a:solidFill>
+                  <a:srgbClr val="E6A36A"/>
+                </a:solidFill>
+                <a:latin typeface="Consolas"/>
+              </a:rPr>
+              <a:t>"ships"</a:t>
+            </a:r>
+            <a:r>
+              <a:rPr sz="1200">
+                <a:solidFill>
+                  <a:srgbClr val="C2D0DA"/>
+                </a:solidFill>
+                <a:latin typeface="Consolas"/>
+              </a:rPr>
               <a:t>,</a:t>
             </a:r>
           </a:p>
@@ -8379,7 +8415,7 @@
                 </a:solidFill>
                 <a:latin typeface="Consolas"/>
               </a:rPr>
-              <a:t>"title"</a:t>
+              <a:t>"itemType"</a:t>
             </a:r>
             <a:r>
               <a:rPr sz="1200">
@@ -8397,7 +8433,7 @@
                 </a:solidFill>
                 <a:latin typeface="Consolas"/>
               </a:rPr>
-              <a:t>"ships"</a:t>
+              <a:t>"movingfeature"</a:t>
             </a:r>
             <a:r>
               <a:rPr sz="1200">
@@ -8437,7 +8473,7 @@
                 </a:solidFill>
                 <a:latin typeface="Consolas"/>
               </a:rPr>
-              <a:t>"itemType"</a:t>
+              <a:t>"description"</a:t>
             </a:r>
             <a:r>
               <a:rPr sz="1200">
@@ -8455,7 +8491,7 @@
                 </a:solidFill>
                 <a:latin typeface="Consolas"/>
               </a:rPr>
-              <a:t>"movingfeature"</a:t>
+              <a:t>"Danish AIS vessel trajectories"</a:t>
             </a:r>
             <a:r>
               <a:rPr sz="1200">
@@ -8495,16 +8531,34 @@
                 </a:solidFill>
                 <a:latin typeface="Consolas"/>
               </a:rPr>
-              <a:t>"description"</a:t>
-            </a:r>
-            <a:r>
-              <a:rPr sz="1200">
-                <a:solidFill>
-                  <a:srgbClr val="C2D0DA"/>
-                </a:solidFill>
-                <a:latin typeface="Consolas"/>
-              </a:rPr>
-              <a:t>: "Danish AIS vessel</a:t>
+              <a:t>"crs"</a:t>
+            </a:r>
+            <a:r>
+              <a:rPr sz="1200">
+                <a:solidFill>
+                  <a:srgbClr val="C2D0DA"/>
+                </a:solidFill>
+                <a:latin typeface="Consolas"/>
+              </a:rPr>
+              <a:t>: [</a:t>
+            </a:r>
+            <a:r>
+              <a:rPr sz="1200">
+                <a:solidFill>
+                  <a:srgbClr val="E6A36A"/>
+                </a:solidFill>
+                <a:latin typeface="Consolas"/>
+              </a:rPr>
+              <a:t>".../def/crs/EPSG/0/25832"</a:t>
+            </a:r>
+            <a:r>
+              <a:rPr sz="1200">
+                <a:solidFill>
+                  <a:srgbClr val="C2D0DA"/>
+                </a:solidFill>
+                <a:latin typeface="Consolas"/>
+              </a:rPr>
+              <a:t>],</a:t>
             </a:r>
           </a:p>
           <a:p>
@@ -8526,7 +8580,25 @@
                 </a:solidFill>
                 <a:latin typeface="Consolas"/>
               </a:rPr>
-              <a:t>                  trajectories</a:t>
+              <a:t>  </a:t>
+            </a:r>
+            <a:r>
+              <a:rPr sz="1200">
+                <a:solidFill>
+                  <a:srgbClr val="6FC3E0"/>
+                </a:solidFill>
+                <a:latin typeface="Consolas"/>
+              </a:rPr>
+              <a:t>"extent"</a:t>
+            </a:r>
+            <a:r>
+              <a:rPr sz="1200">
+                <a:solidFill>
+                  <a:srgbClr val="C2D0DA"/>
+                </a:solidFill>
+                <a:latin typeface="Consolas"/>
+              </a:rPr>
+              <a:t>: {</a:t>
             </a:r>
           </a:p>
           <a:p>
@@ -8548,7 +8620,79 @@
                 </a:solidFill>
                 <a:latin typeface="Consolas"/>
               </a:rPr>
-              <a:t>                  (MobilityDB tgeompoint)"</a:t>
+              <a:t>    </a:t>
+            </a:r>
+            <a:r>
+              <a:rPr sz="1200">
+                <a:solidFill>
+                  <a:srgbClr val="6FC3E0"/>
+                </a:solidFill>
+                <a:latin typeface="Consolas"/>
+              </a:rPr>
+              <a:t>"spatial"</a:t>
+            </a:r>
+            <a:r>
+              <a:rPr sz="1200">
+                <a:solidFill>
+                  <a:srgbClr val="C2D0DA"/>
+                </a:solidFill>
+                <a:latin typeface="Consolas"/>
+              </a:rPr>
+              <a:t>:  { </a:t>
+            </a:r>
+            <a:r>
+              <a:rPr sz="1200">
+                <a:solidFill>
+                  <a:srgbClr val="6FC3E0"/>
+                </a:solidFill>
+                <a:latin typeface="Consolas"/>
+              </a:rPr>
+              <a:t>"bbox"</a:t>
+            </a:r>
+            <a:r>
+              <a:rPr sz="1200">
+                <a:solidFill>
+                  <a:srgbClr val="C2D0DA"/>
+                </a:solidFill>
+                <a:latin typeface="Consolas"/>
+              </a:rPr>
+              <a:t>: [[</a:t>
+            </a:r>
+            <a:r>
+              <a:rPr sz="1200">
+                <a:solidFill>
+                  <a:srgbClr val="C9E08A"/>
+                </a:solidFill>
+                <a:latin typeface="Consolas"/>
+              </a:rPr>
+              <a:t>152625</a:t>
+            </a:r>
+            <a:r>
+              <a:rPr sz="1200">
+                <a:solidFill>
+                  <a:srgbClr val="C2D0DA"/>
+                </a:solidFill>
+                <a:latin typeface="Consolas"/>
+              </a:rPr>
+              <a:t>, </a:t>
+            </a:r>
+            <a:r>
+              <a:rPr sz="1200">
+                <a:solidFill>
+                  <a:srgbClr val="C9E08A"/>
+                </a:solidFill>
+                <a:latin typeface="Consolas"/>
+              </a:rPr>
+              <a:t>5942006</a:t>
+            </a:r>
+            <a:r>
+              <a:rPr sz="1200">
+                <a:solidFill>
+                  <a:srgbClr val="C2D0DA"/>
+                </a:solidFill>
+                <a:latin typeface="Consolas"/>
+              </a:rPr>
+              <a:t>,</a:t>
             </a:r>
           </a:p>
           <a:p>
@@ -8570,6 +8714,372 @@
                 </a:solidFill>
                 <a:latin typeface="Consolas"/>
               </a:rPr>
+              <a:t>                            </a:t>
+            </a:r>
+            <a:r>
+              <a:rPr sz="1200">
+                <a:solidFill>
+                  <a:srgbClr val="C9E08A"/>
+                </a:solidFill>
+                <a:latin typeface="Consolas"/>
+              </a:rPr>
+              <a:t>1020003</a:t>
+            </a:r>
+            <a:r>
+              <a:rPr sz="1200">
+                <a:solidFill>
+                  <a:srgbClr val="C2D0DA"/>
+                </a:solidFill>
+                <a:latin typeface="Consolas"/>
+              </a:rPr>
+              <a:t>, </a:t>
+            </a:r>
+            <a:r>
+              <a:rPr sz="1200">
+                <a:solidFill>
+                  <a:srgbClr val="C9E08A"/>
+                </a:solidFill>
+                <a:latin typeface="Consolas"/>
+              </a:rPr>
+              <a:t>6545239</a:t>
+            </a:r>
+            <a:r>
+              <a:rPr sz="1200">
+                <a:solidFill>
+                  <a:srgbClr val="C2D0DA"/>
+                </a:solidFill>
+                <a:latin typeface="Consolas"/>
+              </a:rPr>
+              <a:t>]] },</a:t>
+            </a:r>
+          </a:p>
+          <a:p>
+            <a:pPr>
+              <a:lnSpc>
+                <a:spcPct val="102000"/>
+              </a:lnSpc>
+              <a:spcBef>
+                <a:spcPts val="0"/>
+              </a:spcBef>
+              <a:spcAft>
+                <a:spcPts val="0"/>
+              </a:spcAft>
+            </a:pPr>
+            <a:r>
+              <a:rPr sz="1200">
+                <a:solidFill>
+                  <a:srgbClr val="C2D0DA"/>
+                </a:solidFill>
+                <a:latin typeface="Consolas"/>
+              </a:rPr>
+              <a:t>    </a:t>
+            </a:r>
+            <a:r>
+              <a:rPr sz="1200">
+                <a:solidFill>
+                  <a:srgbClr val="6FC3E0"/>
+                </a:solidFill>
+                <a:latin typeface="Consolas"/>
+              </a:rPr>
+              <a:t>"temporal"</a:t>
+            </a:r>
+            <a:r>
+              <a:rPr sz="1200">
+                <a:solidFill>
+                  <a:srgbClr val="C2D0DA"/>
+                </a:solidFill>
+                <a:latin typeface="Consolas"/>
+              </a:rPr>
+              <a:t>: { </a:t>
+            </a:r>
+            <a:r>
+              <a:rPr sz="1200">
+                <a:solidFill>
+                  <a:srgbClr val="6FC3E0"/>
+                </a:solidFill>
+                <a:latin typeface="Consolas"/>
+              </a:rPr>
+              <a:t>"interval"</a:t>
+            </a:r>
+            <a:r>
+              <a:rPr sz="1200">
+                <a:solidFill>
+                  <a:srgbClr val="C2D0DA"/>
+                </a:solidFill>
+                <a:latin typeface="Consolas"/>
+              </a:rPr>
+              <a:t>: [[</a:t>
+            </a:r>
+            <a:r>
+              <a:rPr sz="1200">
+                <a:solidFill>
+                  <a:srgbClr val="E6A36A"/>
+                </a:solidFill>
+                <a:latin typeface="Consolas"/>
+              </a:rPr>
+              <a:t>"2026-02-26 ..."</a:t>
+            </a:r>
+            <a:r>
+              <a:rPr sz="1200">
+                <a:solidFill>
+                  <a:srgbClr val="C2D0DA"/>
+                </a:solidFill>
+                <a:latin typeface="Consolas"/>
+              </a:rPr>
+              <a:t>,</a:t>
+            </a:r>
+          </a:p>
+          <a:p>
+            <a:pPr>
+              <a:lnSpc>
+                <a:spcPct val="102000"/>
+              </a:lnSpc>
+              <a:spcBef>
+                <a:spcPts val="0"/>
+              </a:spcBef>
+              <a:spcAft>
+                <a:spcPts val="0"/>
+              </a:spcAft>
+            </a:pPr>
+            <a:r>
+              <a:rPr sz="1200">
+                <a:solidFill>
+                  <a:srgbClr val="C2D0DA"/>
+                </a:solidFill>
+                <a:latin typeface="Consolas"/>
+              </a:rPr>
+              <a:t>                                </a:t>
+            </a:r>
+            <a:r>
+              <a:rPr sz="1200">
+                <a:solidFill>
+                  <a:srgbClr val="E6A36A"/>
+                </a:solidFill>
+                <a:latin typeface="Consolas"/>
+              </a:rPr>
+              <a:t>"2026-02-27 ..."</a:t>
+            </a:r>
+            <a:r>
+              <a:rPr sz="1200">
+                <a:solidFill>
+                  <a:srgbClr val="C2D0DA"/>
+                </a:solidFill>
+                <a:latin typeface="Consolas"/>
+              </a:rPr>
+              <a:t>]] } },</a:t>
+            </a:r>
+          </a:p>
+          <a:p>
+            <a:pPr>
+              <a:lnSpc>
+                <a:spcPct val="102000"/>
+              </a:lnSpc>
+              <a:spcBef>
+                <a:spcPts val="0"/>
+              </a:spcBef>
+              <a:spcAft>
+                <a:spcPts val="0"/>
+              </a:spcAft>
+            </a:pPr>
+            <a:r>
+              <a:rPr sz="1200">
+                <a:solidFill>
+                  <a:srgbClr val="C2D0DA"/>
+                </a:solidFill>
+                <a:latin typeface="Consolas"/>
+              </a:rPr>
+              <a:t>  </a:t>
+            </a:r>
+            <a:r>
+              <a:rPr sz="1200">
+                <a:solidFill>
+                  <a:srgbClr val="6FC3E0"/>
+                </a:solidFill>
+                <a:latin typeface="Consolas"/>
+              </a:rPr>
+              <a:t>"links"</a:t>
+            </a:r>
+            <a:r>
+              <a:rPr sz="1200">
+                <a:solidFill>
+                  <a:srgbClr val="C2D0DA"/>
+                </a:solidFill>
+                <a:latin typeface="Consolas"/>
+              </a:rPr>
+              <a:t>: [ { </a:t>
+            </a:r>
+            <a:r>
+              <a:rPr sz="1200">
+                <a:solidFill>
+                  <a:srgbClr val="6FC3E0"/>
+                </a:solidFill>
+                <a:latin typeface="Consolas"/>
+              </a:rPr>
+              <a:t>"rel"</a:t>
+            </a:r>
+            <a:r>
+              <a:rPr sz="1200">
+                <a:solidFill>
+                  <a:srgbClr val="C2D0DA"/>
+                </a:solidFill>
+                <a:latin typeface="Consolas"/>
+              </a:rPr>
+              <a:t>: </a:t>
+            </a:r>
+            <a:r>
+              <a:rPr sz="1200">
+                <a:solidFill>
+                  <a:srgbClr val="E6A36A"/>
+                </a:solidFill>
+                <a:latin typeface="Consolas"/>
+              </a:rPr>
+              <a:t>"self"</a:t>
+            </a:r>
+            <a:r>
+              <a:rPr sz="1200">
+                <a:solidFill>
+                  <a:srgbClr val="C2D0DA"/>
+                </a:solidFill>
+                <a:latin typeface="Consolas"/>
+              </a:rPr>
+              <a:t> },</a:t>
+            </a:r>
+          </a:p>
+          <a:p>
+            <a:pPr>
+              <a:lnSpc>
+                <a:spcPct val="102000"/>
+              </a:lnSpc>
+              <a:spcBef>
+                <a:spcPts val="0"/>
+              </a:spcBef>
+              <a:spcAft>
+                <a:spcPts val="0"/>
+              </a:spcAft>
+            </a:pPr>
+            <a:r>
+              <a:rPr sz="1200">
+                <a:solidFill>
+                  <a:srgbClr val="C2D0DA"/>
+                </a:solidFill>
+                <a:latin typeface="Consolas"/>
+              </a:rPr>
+              <a:t>             { </a:t>
+            </a:r>
+            <a:r>
+              <a:rPr sz="1200">
+                <a:solidFill>
+                  <a:srgbClr val="6FC3E0"/>
+                </a:solidFill>
+                <a:latin typeface="Consolas"/>
+              </a:rPr>
+              <a:t>"rel"</a:t>
+            </a:r>
+            <a:r>
+              <a:rPr sz="1200">
+                <a:solidFill>
+                  <a:srgbClr val="C2D0DA"/>
+                </a:solidFill>
+                <a:latin typeface="Consolas"/>
+              </a:rPr>
+              <a:t>: </a:t>
+            </a:r>
+            <a:r>
+              <a:rPr sz="1200">
+                <a:solidFill>
+                  <a:srgbClr val="E6A36A"/>
+                </a:solidFill>
+                <a:latin typeface="Consolas"/>
+              </a:rPr>
+              <a:t>"items"</a:t>
+            </a:r>
+            <a:r>
+              <a:rPr sz="1200">
+                <a:solidFill>
+                  <a:srgbClr val="C2D0DA"/>
+                </a:solidFill>
+                <a:latin typeface="Consolas"/>
+              </a:rPr>
+              <a:t> },</a:t>
+            </a:r>
+          </a:p>
+          <a:p>
+            <a:pPr>
+              <a:lnSpc>
+                <a:spcPct val="102000"/>
+              </a:lnSpc>
+              <a:spcBef>
+                <a:spcPts val="0"/>
+              </a:spcBef>
+              <a:spcAft>
+                <a:spcPts val="0"/>
+              </a:spcAft>
+            </a:pPr>
+            <a:r>
+              <a:rPr sz="1200">
+                <a:solidFill>
+                  <a:srgbClr val="C2D0DA"/>
+                </a:solidFill>
+                <a:latin typeface="Consolas"/>
+              </a:rPr>
+              <a:t>             { </a:t>
+            </a:r>
+            <a:r>
+              <a:rPr sz="1200">
+                <a:solidFill>
+                  <a:srgbClr val="6FC3E0"/>
+                </a:solidFill>
+                <a:latin typeface="Consolas"/>
+              </a:rPr>
+              <a:t>"rel"</a:t>
+            </a:r>
+            <a:r>
+              <a:rPr sz="1200">
+                <a:solidFill>
+                  <a:srgbClr val="C2D0DA"/>
+                </a:solidFill>
+                <a:latin typeface="Consolas"/>
+              </a:rPr>
+              <a:t>: </a:t>
+            </a:r>
+            <a:r>
+              <a:rPr sz="1200">
+                <a:solidFill>
+                  <a:srgbClr val="E6A36A"/>
+                </a:solidFill>
+                <a:latin typeface="Consolas"/>
+              </a:rPr>
+              <a:t>"enclosure"</a:t>
+            </a:r>
+            <a:r>
+              <a:rPr sz="1200">
+                <a:solidFill>
+                  <a:srgbClr val="C2D0DA"/>
+                </a:solidFill>
+                <a:latin typeface="Consolas"/>
+              </a:rPr>
+              <a:t> } ]</a:t>
+            </a:r>
+          </a:p>
+          <a:p>
+            <a:pPr>
+              <a:lnSpc>
+                <a:spcPct val="102000"/>
+              </a:lnSpc>
+              <a:spcBef>
+                <a:spcPts val="0"/>
+              </a:spcBef>
+              <a:spcAft>
+                <a:spcPts val="0"/>
+              </a:spcAft>
+            </a:pPr>
+            <a:r>
+              <a:rPr sz="1200">
+                <a:solidFill>
+                  <a:srgbClr val="C2D0DA"/>
+                </a:solidFill>
+                <a:latin typeface="Consolas"/>
+              </a:rPr>
               <a:t>}</a:t>
             </a:r>
           </a:p>
@@ -8583,8 +9093,8 @@
         </p:nvSpPr>
         <p:spPr>
           <a:xfrm>
-            <a:off x="6281928" y="4526280"/>
-            <a:ext cx="5342839" cy="1463040"/>
+            <a:off x="6281928" y="5029200"/>
+            <a:ext cx="5342839" cy="1097280"/>
           </a:xfrm>
           <a:prstGeom prst="rect">
             <a:avLst/>
@@ -8624,7 +9134,7 @@
                 </a:solidFill>
                 <a:latin typeface="Calibri"/>
               </a:rPr>
-              <a:t>itemType is movingfeature, per OGC API – Moving Features</a:t>
+              <a:t>extent is the spatial bbox and time interval of the collection</a:t>
             </a:r>
           </a:p>
           <a:p>
@@ -8655,7 +9165,7 @@
                 </a:solidFill>
                 <a:latin typeface="Calibri"/>
               </a:rPr>
-              <a:t>Links are relative; the client follows them without hard-coding paths</a:t>
+              <a:t>crs and links round out the standard collection resource</a:t>
             </a:r>
           </a:p>
         </p:txBody>
@@ -9491,7 +10001,61 @@
                 </a:solidFill>
                 <a:latin typeface="Consolas"/>
               </a:rPr>
-              <a:t>"temporalGeometry"</a:t>
+              <a:t>"crs"</a:t>
+            </a:r>
+            <a:r>
+              <a:rPr sz="1200">
+                <a:solidFill>
+                  <a:srgbClr val="C2D0DA"/>
+                </a:solidFill>
+                <a:latin typeface="Consolas"/>
+              </a:rPr>
+              <a:t>: { </a:t>
+            </a:r>
+            <a:r>
+              <a:rPr sz="1200">
+                <a:solidFill>
+                  <a:srgbClr val="6FC3E0"/>
+                </a:solidFill>
+                <a:latin typeface="Consolas"/>
+              </a:rPr>
+              <a:t>"type"</a:t>
+            </a:r>
+            <a:r>
+              <a:rPr sz="1200">
+                <a:solidFill>
+                  <a:srgbClr val="C2D0DA"/>
+                </a:solidFill>
+                <a:latin typeface="Consolas"/>
+              </a:rPr>
+              <a:t>: </a:t>
+            </a:r>
+            <a:r>
+              <a:rPr sz="1200">
+                <a:solidFill>
+                  <a:srgbClr val="E6A36A"/>
+                </a:solidFill>
+                <a:latin typeface="Consolas"/>
+              </a:rPr>
+              <a:t>"Name"</a:t>
+            </a:r>
+            <a:r>
+              <a:rPr sz="1200">
+                <a:solidFill>
+                  <a:srgbClr val="C2D0DA"/>
+                </a:solidFill>
+                <a:latin typeface="Consolas"/>
+              </a:rPr>
+              <a:t>, </a:t>
+            </a:r>
+            <a:r>
+              <a:rPr sz="1200">
+                <a:solidFill>
+                  <a:srgbClr val="6FC3E0"/>
+                </a:solidFill>
+                <a:latin typeface="Consolas"/>
+              </a:rPr>
+              <a:t>"properties"</a:t>
             </a:r>
             <a:r>
               <a:rPr sz="1200">
@@ -9531,7 +10095,7 @@
                 </a:solidFill>
                 <a:latin typeface="Consolas"/>
               </a:rPr>
-              <a:t>"type"</a:t>
+              <a:t>"name"</a:t>
             </a:r>
             <a:r>
               <a:rPr sz="1200">
@@ -9549,16 +10113,16 @@
                 </a:solidFill>
                 <a:latin typeface="Consolas"/>
               </a:rPr>
-              <a:t>"MovingPoint"</a:t>
-            </a:r>
-            <a:r>
-              <a:rPr sz="1200">
-                <a:solidFill>
-                  <a:srgbClr val="C2D0DA"/>
-                </a:solidFill>
-                <a:latin typeface="Consolas"/>
-              </a:rPr>
-              <a:t>,</a:t>
+              <a:t>"urn:ogc:def:crs:EPSG::25832"</a:t>
+            </a:r>
+            <a:r>
+              <a:rPr sz="1200">
+                <a:solidFill>
+                  <a:srgbClr val="C2D0DA"/>
+                </a:solidFill>
+                <a:latin typeface="Consolas"/>
+              </a:rPr>
+              <a:t> } },</a:t>
             </a:r>
           </a:p>
           <a:p>
@@ -9580,7 +10144,7 @@
                 </a:solidFill>
                 <a:latin typeface="Consolas"/>
               </a:rPr>
-              <a:t>        </a:t>
+              <a:t>      </a:t>
             </a:r>
             <a:r>
               <a:rPr sz="1200">
@@ -9589,52 +10153,88 @@
                 </a:solidFill>
                 <a:latin typeface="Consolas"/>
               </a:rPr>
-              <a:t>"crs"</a:t>
-            </a:r>
-            <a:r>
-              <a:rPr sz="1200">
-                <a:solidFill>
-                  <a:srgbClr val="C2D0DA"/>
-                </a:solidFill>
-                <a:latin typeface="Consolas"/>
-              </a:rPr>
-              <a:t>: { </a:t>
-            </a:r>
-            <a:r>
-              <a:rPr sz="1200">
-                <a:solidFill>
-                  <a:srgbClr val="6FC3E0"/>
-                </a:solidFill>
-                <a:latin typeface="Consolas"/>
-              </a:rPr>
-              <a:t>"type"</a:t>
-            </a:r>
-            <a:r>
-              <a:rPr sz="1200">
-                <a:solidFill>
-                  <a:srgbClr val="C2D0DA"/>
-                </a:solidFill>
-                <a:latin typeface="Consolas"/>
-              </a:rPr>
-              <a:t>: </a:t>
-            </a:r>
-            <a:r>
-              <a:rPr sz="1200">
-                <a:solidFill>
-                  <a:srgbClr val="E6A36A"/>
-                </a:solidFill>
-                <a:latin typeface="Consolas"/>
-              </a:rPr>
-              <a:t>"Name"</a:t>
-            </a:r>
-            <a:r>
-              <a:rPr sz="1200">
-                <a:solidFill>
-                  <a:srgbClr val="C2D0DA"/>
-                </a:solidFill>
-                <a:latin typeface="Consolas"/>
-              </a:rPr>
-              <a:t>,</a:t>
+              <a:t>"bbox"</a:t>
+            </a:r>
+            <a:r>
+              <a:rPr sz="1200">
+                <a:solidFill>
+                  <a:srgbClr val="C2D0DA"/>
+                </a:solidFill>
+                <a:latin typeface="Consolas"/>
+              </a:rPr>
+              <a:t>: [</a:t>
+            </a:r>
+            <a:r>
+              <a:rPr sz="1200">
+                <a:solidFill>
+                  <a:srgbClr val="C9E08A"/>
+                </a:solidFill>
+                <a:latin typeface="Consolas"/>
+              </a:rPr>
+              <a:t>550889</a:t>
+            </a:r>
+            <a:r>
+              <a:rPr sz="1200">
+                <a:solidFill>
+                  <a:srgbClr val="C2D0DA"/>
+                </a:solidFill>
+                <a:latin typeface="Consolas"/>
+              </a:rPr>
+              <a:t>, </a:t>
+            </a:r>
+            <a:r>
+              <a:rPr sz="1200">
+                <a:solidFill>
+                  <a:srgbClr val="C9E08A"/>
+                </a:solidFill>
+                <a:latin typeface="Consolas"/>
+              </a:rPr>
+              <a:t>6328752</a:t>
+            </a:r>
+            <a:r>
+              <a:rPr sz="1200">
+                <a:solidFill>
+                  <a:srgbClr val="C2D0DA"/>
+                </a:solidFill>
+                <a:latin typeface="Consolas"/>
+              </a:rPr>
+              <a:t>, </a:t>
+            </a:r>
+            <a:r>
+              <a:rPr sz="1200">
+                <a:solidFill>
+                  <a:srgbClr val="C9E08A"/>
+                </a:solidFill>
+                <a:latin typeface="Consolas"/>
+              </a:rPr>
+              <a:t>616716</a:t>
+            </a:r>
+            <a:r>
+              <a:rPr sz="1200">
+                <a:solidFill>
+                  <a:srgbClr val="C2D0DA"/>
+                </a:solidFill>
+                <a:latin typeface="Consolas"/>
+              </a:rPr>
+              <a:t>, </a:t>
+            </a:r>
+            <a:r>
+              <a:rPr sz="1200">
+                <a:solidFill>
+                  <a:srgbClr val="C9E08A"/>
+                </a:solidFill>
+                <a:latin typeface="Consolas"/>
+              </a:rPr>
+              <a:t>6346258</a:t>
+            </a:r>
+            <a:r>
+              <a:rPr sz="1200">
+                <a:solidFill>
+                  <a:srgbClr val="C2D0DA"/>
+                </a:solidFill>
+                <a:latin typeface="Consolas"/>
+              </a:rPr>
+              <a:t>],</a:t>
             </a:r>
           </a:p>
           <a:p>
@@ -9656,7 +10256,7 @@
                 </a:solidFill>
                 <a:latin typeface="Consolas"/>
               </a:rPr>
-              <a:t>                 </a:t>
+              <a:t>      </a:t>
             </a:r>
             <a:r>
               <a:rPr sz="1200">
@@ -9665,34 +10265,16 @@
                 </a:solidFill>
                 <a:latin typeface="Consolas"/>
               </a:rPr>
-              <a:t>"properties"</a:t>
-            </a:r>
-            <a:r>
-              <a:rPr sz="1200">
-                <a:solidFill>
-                  <a:srgbClr val="C2D0DA"/>
-                </a:solidFill>
-                <a:latin typeface="Consolas"/>
-              </a:rPr>
-              <a:t>: { </a:t>
-            </a:r>
-            <a:r>
-              <a:rPr sz="1200">
-                <a:solidFill>
-                  <a:srgbClr val="6FC3E0"/>
-                </a:solidFill>
-                <a:latin typeface="Consolas"/>
-              </a:rPr>
-              <a:t>"name"</a:t>
-            </a:r>
-            <a:r>
-              <a:rPr sz="1200">
-                <a:solidFill>
-                  <a:srgbClr val="C2D0DA"/>
-                </a:solidFill>
-                <a:latin typeface="Consolas"/>
-              </a:rPr>
-              <a:t>: </a:t>
+              <a:t>"time"</a:t>
+            </a:r>
+            <a:r>
+              <a:rPr sz="1200">
+                <a:solidFill>
+                  <a:srgbClr val="C2D0DA"/>
+                </a:solidFill>
+                <a:latin typeface="Consolas"/>
+              </a:rPr>
+              <a:t>: [</a:t>
             </a:r>
             <a:r>
               <a:rPr sz="1200">
@@ -9701,16 +10283,34 @@
                 </a:solidFill>
                 <a:latin typeface="Consolas"/>
               </a:rPr>
-              <a:t>"urn:ogc:def:crs:EPSG::25832"</a:t>
-            </a:r>
-            <a:r>
-              <a:rPr sz="1200">
-                <a:solidFill>
-                  <a:srgbClr val="C2D0DA"/>
-                </a:solidFill>
-                <a:latin typeface="Consolas"/>
-              </a:rPr>
-              <a:t> } },</a:t>
+              <a:t>"2026-02-26 13:28:08+01"</a:t>
+            </a:r>
+            <a:r>
+              <a:rPr sz="1200">
+                <a:solidFill>
+                  <a:srgbClr val="C2D0DA"/>
+                </a:solidFill>
+                <a:latin typeface="Consolas"/>
+              </a:rPr>
+              <a:t>, </a:t>
+            </a:r>
+            <a:r>
+              <a:rPr sz="1200">
+                <a:solidFill>
+                  <a:srgbClr val="E6A36A"/>
+                </a:solidFill>
+                <a:latin typeface="Consolas"/>
+              </a:rPr>
+              <a:t>"2026-02-26 14:41:04+01"</a:t>
+            </a:r>
+            <a:r>
+              <a:rPr sz="1200">
+                <a:solidFill>
+                  <a:srgbClr val="C2D0DA"/>
+                </a:solidFill>
+                <a:latin typeface="Consolas"/>
+              </a:rPr>
+              <a:t>],</a:t>
             </a:r>
           </a:p>
           <a:p>
@@ -9732,7 +10332,7 @@
                 </a:solidFill>
                 <a:latin typeface="Consolas"/>
               </a:rPr>
-              <a:t>        </a:t>
+              <a:t>      </a:t>
             </a:r>
             <a:r>
               <a:rPr sz="1200">
@@ -9741,16 +10341,16 @@
                 </a:solidFill>
                 <a:latin typeface="Consolas"/>
               </a:rPr>
-              <a:t>"sequences"</a:t>
-            </a:r>
-            <a:r>
-              <a:rPr sz="1200">
-                <a:solidFill>
-                  <a:srgbClr val="C2D0DA"/>
-                </a:solidFill>
-                <a:latin typeface="Consolas"/>
-              </a:rPr>
-              <a:t>: [ { </a:t>
+              <a:t>"temporalGeometry"</a:t>
+            </a:r>
+            <a:r>
+              <a:rPr sz="1200">
+                <a:solidFill>
+                  <a:srgbClr val="C2D0DA"/>
+                </a:solidFill>
+                <a:latin typeface="Consolas"/>
+              </a:rPr>
+              <a:t>: { </a:t>
             </a:r>
             <a:r>
               <a:rPr sz="1200">
@@ -9759,16 +10359,16 @@
                 </a:solidFill>
                 <a:latin typeface="Consolas"/>
               </a:rPr>
-              <a:t>"datetimes"</a:t>
-            </a:r>
-            <a:r>
-              <a:rPr sz="1200">
-                <a:solidFill>
-                  <a:srgbClr val="C2D0DA"/>
-                </a:solidFill>
-                <a:latin typeface="Consolas"/>
-              </a:rPr>
-              <a:t>: [</a:t>
+              <a:t>"type"</a:t>
+            </a:r>
+            <a:r>
+              <a:rPr sz="1200">
+                <a:solidFill>
+                  <a:srgbClr val="C2D0DA"/>
+                </a:solidFill>
+                <a:latin typeface="Consolas"/>
+              </a:rPr>
+              <a:t>: </a:t>
             </a:r>
             <a:r>
               <a:rPr sz="1200">
@@ -9777,16 +10377,16 @@
                 </a:solidFill>
                 <a:latin typeface="Consolas"/>
               </a:rPr>
-              <a:t>"2026-02-26T13:28:08+01"</a:t>
-            </a:r>
-            <a:r>
-              <a:rPr sz="1200">
-                <a:solidFill>
-                  <a:srgbClr val="C2D0DA"/>
-                </a:solidFill>
-                <a:latin typeface="Consolas"/>
-              </a:rPr>
-              <a:t>, ...],</a:t>
+              <a:t>"MovingPoint"</a:t>
+            </a:r>
+            <a:r>
+              <a:rPr sz="1200">
+                <a:solidFill>
+                  <a:srgbClr val="C2D0DA"/>
+                </a:solidFill>
+                <a:latin typeface="Consolas"/>
+              </a:rPr>
+              <a:t>,</a:t>
             </a:r>
           </a:p>
           <a:p>
@@ -9808,7 +10408,7 @@
                 </a:solidFill>
                 <a:latin typeface="Consolas"/>
               </a:rPr>
-              <a:t>                         </a:t>
+              <a:t>        </a:t>
             </a:r>
             <a:r>
               <a:rPr sz="1200">
@@ -9817,6 +10417,42 @@
                 </a:solidFill>
                 <a:latin typeface="Consolas"/>
               </a:rPr>
+              <a:t>"sequences"</a:t>
+            </a:r>
+            <a:r>
+              <a:rPr sz="1200">
+                <a:solidFill>
+                  <a:srgbClr val="C2D0DA"/>
+                </a:solidFill>
+                <a:latin typeface="Consolas"/>
+              </a:rPr>
+              <a:t>: [ { </a:t>
+            </a:r>
+            <a:r>
+              <a:rPr sz="1200">
+                <a:solidFill>
+                  <a:srgbClr val="6FC3E0"/>
+                </a:solidFill>
+                <a:latin typeface="Consolas"/>
+              </a:rPr>
+              <a:t>"datetimes"</a:t>
+            </a:r>
+            <a:r>
+              <a:rPr sz="1200">
+                <a:solidFill>
+                  <a:srgbClr val="C2D0DA"/>
+                </a:solidFill>
+                <a:latin typeface="Consolas"/>
+              </a:rPr>
+              <a:t>: [...], </a:t>
+            </a:r>
+            <a:r>
+              <a:rPr sz="1200">
+                <a:solidFill>
+                  <a:srgbClr val="6FC3E0"/>
+                </a:solidFill>
+                <a:latin typeface="Consolas"/>
+              </a:rPr>
               <a:t>"coordinates"</a:t>
             </a:r>
             <a:r>
@@ -9826,43 +10462,7 @@
                 </a:solidFill>
                 <a:latin typeface="Consolas"/>
               </a:rPr>
-              <a:t>: [[</a:t>
-            </a:r>
-            <a:r>
-              <a:rPr sz="1200">
-                <a:solidFill>
-                  <a:srgbClr val="C9E08A"/>
-                </a:solidFill>
-                <a:latin typeface="Consolas"/>
-              </a:rPr>
-              <a:t>721000.4</a:t>
-            </a:r>
-            <a:r>
-              <a:rPr sz="1200">
-                <a:solidFill>
-                  <a:srgbClr val="C2D0DA"/>
-                </a:solidFill>
-                <a:latin typeface="Consolas"/>
-              </a:rPr>
-              <a:t>, </a:t>
-            </a:r>
-            <a:r>
-              <a:rPr sz="1200">
-                <a:solidFill>
-                  <a:srgbClr val="C9E08A"/>
-                </a:solidFill>
-                <a:latin typeface="Consolas"/>
-              </a:rPr>
-              <a:t>6178001.2</a:t>
-            </a:r>
-            <a:r>
-              <a:rPr sz="1200">
-                <a:solidFill>
-                  <a:srgbClr val="C2D0DA"/>
-                </a:solidFill>
-                <a:latin typeface="Consolas"/>
-              </a:rPr>
-              <a:t>], ...] } ],</a:t>
+              <a:t>: [...] } ],</a:t>
             </a:r>
           </a:p>
           <a:p>
@@ -9920,7 +10520,119 @@
                 </a:solidFill>
                 <a:latin typeface="Consolas"/>
               </a:rPr>
-              <a:t> } },</a:t>
+              <a:t> },</a:t>
+            </a:r>
+          </a:p>
+          <a:p>
+            <a:pPr>
+              <a:lnSpc>
+                <a:spcPct val="102000"/>
+              </a:lnSpc>
+              <a:spcBef>
+                <a:spcPts val="0"/>
+              </a:spcBef>
+              <a:spcAft>
+                <a:spcPts val="0"/>
+              </a:spcAft>
+            </a:pPr>
+            <a:r>
+              <a:rPr sz="1200">
+                <a:solidFill>
+                  <a:srgbClr val="C2D0DA"/>
+                </a:solidFill>
+                <a:latin typeface="Consolas"/>
+              </a:rPr>
+              <a:t>      </a:t>
+            </a:r>
+            <a:r>
+              <a:rPr sz="1200">
+                <a:solidFill>
+                  <a:srgbClr val="6FC3E0"/>
+                </a:solidFill>
+                <a:latin typeface="Consolas"/>
+              </a:rPr>
+              <a:t>"links"</a:t>
+            </a:r>
+            <a:r>
+              <a:rPr sz="1200">
+                <a:solidFill>
+                  <a:srgbClr val="C2D0DA"/>
+                </a:solidFill>
+                <a:latin typeface="Consolas"/>
+              </a:rPr>
+              <a:t>: [ { </a:t>
+            </a:r>
+            <a:r>
+              <a:rPr sz="1200">
+                <a:solidFill>
+                  <a:srgbClr val="6FC3E0"/>
+                </a:solidFill>
+                <a:latin typeface="Consolas"/>
+              </a:rPr>
+              <a:t>"rel"</a:t>
+            </a:r>
+            <a:r>
+              <a:rPr sz="1200">
+                <a:solidFill>
+                  <a:srgbClr val="C2D0DA"/>
+                </a:solidFill>
+                <a:latin typeface="Consolas"/>
+              </a:rPr>
+              <a:t>: </a:t>
+            </a:r>
+            <a:r>
+              <a:rPr sz="1200">
+                <a:solidFill>
+                  <a:srgbClr val="E6A36A"/>
+                </a:solidFill>
+                <a:latin typeface="Consolas"/>
+              </a:rPr>
+              <a:t>"self"</a:t>
+            </a:r>
+            <a:r>
+              <a:rPr sz="1200">
+                <a:solidFill>
+                  <a:srgbClr val="C2D0DA"/>
+                </a:solidFill>
+                <a:latin typeface="Consolas"/>
+              </a:rPr>
+              <a:t>, </a:t>
+            </a:r>
+            <a:r>
+              <a:rPr sz="1200">
+                <a:solidFill>
+                  <a:srgbClr val="6FC3E0"/>
+                </a:solidFill>
+                <a:latin typeface="Consolas"/>
+              </a:rPr>
+              <a:t>"href"</a:t>
+            </a:r>
+            <a:r>
+              <a:rPr sz="1200">
+                <a:solidFill>
+                  <a:srgbClr val="C2D0DA"/>
+                </a:solidFill>
+                <a:latin typeface="Consolas"/>
+              </a:rPr>
+              <a:t>: </a:t>
+            </a:r>
+            <a:r>
+              <a:rPr sz="1200">
+                <a:solidFill>
+                  <a:srgbClr val="E6A36A"/>
+                </a:solidFill>
+                <a:latin typeface="Consolas"/>
+              </a:rPr>
+              <a:t>".../items/1"</a:t>
+            </a:r>
+            <a:r>
+              <a:rPr sz="1200">
+                <a:solidFill>
+                  <a:srgbClr val="C2D0DA"/>
+                </a:solidFill>
+                <a:latin typeface="Consolas"/>
+              </a:rPr>
+              <a:t> } ] },</a:t>
             </a:r>
           </a:p>
           <a:p>
@@ -10826,7 +11538,7 @@
         <p:spPr>
           <a:xfrm>
             <a:off x="566928" y="1874519"/>
-            <a:ext cx="6035040" cy="4206240"/>
+            <a:ext cx="6629400" cy="4480560"/>
           </a:xfrm>
           <a:prstGeom prst="roundRect">
             <a:avLst>
@@ -10872,7 +11584,7 @@
         <p:spPr>
           <a:xfrm>
             <a:off x="694944" y="1965960"/>
-            <a:ext cx="5779007" cy="4023359"/>
+            <a:ext cx="6373368" cy="4297680"/>
           </a:xfrm>
           <a:prstGeom prst="rect">
             <a:avLst/>
@@ -10992,6 +11704,42 @@
                 </a:solidFill>
                 <a:latin typeface="Consolas"/>
               </a:rPr>
+              <a:t>, </a:t>
+            </a:r>
+            <a:r>
+              <a:rPr sz="1200">
+                <a:solidFill>
+                  <a:srgbClr val="6FC3E0"/>
+                </a:solidFill>
+                <a:latin typeface="Consolas"/>
+              </a:rPr>
+              <a:t>"type"</a:t>
+            </a:r>
+            <a:r>
+              <a:rPr sz="1200">
+                <a:solidFill>
+                  <a:srgbClr val="C2D0DA"/>
+                </a:solidFill>
+                <a:latin typeface="Consolas"/>
+              </a:rPr>
+              <a:t>: </a:t>
+            </a:r>
+            <a:r>
+              <a:rPr sz="1200">
+                <a:solidFill>
+                  <a:srgbClr val="E6A36A"/>
+                </a:solidFill>
+                <a:latin typeface="Consolas"/>
+              </a:rPr>
+              <a:t>"Feature"</a:t>
+            </a:r>
+            <a:r>
+              <a:rPr sz="1200">
+                <a:solidFill>
+                  <a:srgbClr val="C2D0DA"/>
+                </a:solidFill>
+                <a:latin typeface="Consolas"/>
+              </a:rPr>
               <a:t>,</a:t>
             </a:r>
           </a:p>
@@ -11023,7 +11771,25 @@
                 </a:solidFill>
                 <a:latin typeface="Consolas"/>
               </a:rPr>
-              <a:t>"type"</a:t>
+              <a:t>"properties"</a:t>
+            </a:r>
+            <a:r>
+              <a:rPr sz="1200">
+                <a:solidFill>
+                  <a:srgbClr val="C2D0DA"/>
+                </a:solidFill>
+                <a:latin typeface="Consolas"/>
+              </a:rPr>
+              <a:t>: { </a:t>
+            </a:r>
+            <a:r>
+              <a:rPr sz="1200">
+                <a:solidFill>
+                  <a:srgbClr val="6FC3E0"/>
+                </a:solidFill>
+                <a:latin typeface="Consolas"/>
+              </a:rPr>
+              <a:t>"mmsi"</a:t>
             </a:r>
             <a:r>
               <a:rPr sz="1200">
@@ -11037,20 +11803,56 @@
             <a:r>
               <a:rPr sz="1200">
                 <a:solidFill>
+                  <a:srgbClr val="C9E08A"/>
+                </a:solidFill>
+                <a:latin typeface="Consolas"/>
+              </a:rPr>
+              <a:t>111219510</a:t>
+            </a:r>
+            <a:r>
+              <a:rPr sz="1200">
+                <a:solidFill>
+                  <a:srgbClr val="C2D0DA"/>
+                </a:solidFill>
+                <a:latin typeface="Consolas"/>
+              </a:rPr>
+              <a:t>, </a:t>
+            </a:r>
+            <a:r>
+              <a:rPr sz="1200">
+                <a:solidFill>
+                  <a:srgbClr val="6FC3E0"/>
+                </a:solidFill>
+                <a:latin typeface="Consolas"/>
+              </a:rPr>
+              <a:t>"name"</a:t>
+            </a:r>
+            <a:r>
+              <a:rPr sz="1200">
+                <a:solidFill>
+                  <a:srgbClr val="C2D0DA"/>
+                </a:solidFill>
+                <a:latin typeface="Consolas"/>
+              </a:rPr>
+              <a:t>: </a:t>
+            </a:r>
+            <a:r>
+              <a:rPr sz="1200">
+                <a:solidFill>
                   <a:srgbClr val="E6A36A"/>
                 </a:solidFill>
                 <a:latin typeface="Consolas"/>
               </a:rPr>
-              <a:t>"Feature"</a:t>
-            </a:r>
-            <a:r>
-              <a:rPr sz="1200">
-                <a:solidFill>
-                  <a:srgbClr val="C2D0DA"/>
-                </a:solidFill>
-                <a:latin typeface="Consolas"/>
-              </a:rPr>
-              <a:t>,</a:t>
+              <a:t>"vessel 111219510"</a:t>
+            </a:r>
+            <a:r>
+              <a:rPr sz="1200">
+                <a:solidFill>
+                  <a:srgbClr val="C2D0DA"/>
+                </a:solidFill>
+                <a:latin typeface="Consolas"/>
+              </a:rPr>
+              <a:t> },</a:t>
             </a:r>
           </a:p>
           <a:p>
@@ -11081,6 +11883,60 @@
                 </a:solidFill>
                 <a:latin typeface="Consolas"/>
               </a:rPr>
+              <a:t>"crs"</a:t>
+            </a:r>
+            <a:r>
+              <a:rPr sz="1200">
+                <a:solidFill>
+                  <a:srgbClr val="C2D0DA"/>
+                </a:solidFill>
+                <a:latin typeface="Consolas"/>
+              </a:rPr>
+              <a:t>: { </a:t>
+            </a:r>
+            <a:r>
+              <a:rPr sz="1200">
+                <a:solidFill>
+                  <a:srgbClr val="6FC3E0"/>
+                </a:solidFill>
+                <a:latin typeface="Consolas"/>
+              </a:rPr>
+              <a:t>"type"</a:t>
+            </a:r>
+            <a:r>
+              <a:rPr sz="1200">
+                <a:solidFill>
+                  <a:srgbClr val="C2D0DA"/>
+                </a:solidFill>
+                <a:latin typeface="Consolas"/>
+              </a:rPr>
+              <a:t>: </a:t>
+            </a:r>
+            <a:r>
+              <a:rPr sz="1200">
+                <a:solidFill>
+                  <a:srgbClr val="E6A36A"/>
+                </a:solidFill>
+                <a:latin typeface="Consolas"/>
+              </a:rPr>
+              <a:t>"Name"</a:t>
+            </a:r>
+            <a:r>
+              <a:rPr sz="1200">
+                <a:solidFill>
+                  <a:srgbClr val="C2D0DA"/>
+                </a:solidFill>
+                <a:latin typeface="Consolas"/>
+              </a:rPr>
+              <a:t>, </a:t>
+            </a:r>
+            <a:r>
+              <a:rPr sz="1200">
+                <a:solidFill>
+                  <a:srgbClr val="6FC3E0"/>
+                </a:solidFill>
+                <a:latin typeface="Consolas"/>
+              </a:rPr>
               <a:t>"properties"</a:t>
             </a:r>
             <a:r>
@@ -11121,7 +11977,7 @@
                 </a:solidFill>
                 <a:latin typeface="Consolas"/>
               </a:rPr>
-              <a:t>"mmsi"</a:t>
+              <a:t>"name"</a:t>
             </a:r>
             <a:r>
               <a:rPr sz="1200">
@@ -11135,20 +11991,20 @@
             <a:r>
               <a:rPr sz="1200">
                 <a:solidFill>
-                  <a:srgbClr val="C9E08A"/>
-                </a:solidFill>
-                <a:latin typeface="Consolas"/>
-              </a:rPr>
-              <a:t>111219510</a:t>
-            </a:r>
-            <a:r>
-              <a:rPr sz="1200">
-                <a:solidFill>
-                  <a:srgbClr val="C2D0DA"/>
-                </a:solidFill>
-                <a:latin typeface="Consolas"/>
-              </a:rPr>
-              <a:t>,</a:t>
+                  <a:srgbClr val="E6A36A"/>
+                </a:solidFill>
+                <a:latin typeface="Consolas"/>
+              </a:rPr>
+              <a:t>"urn:ogc:def:crs:EPSG::25832"</a:t>
+            </a:r>
+            <a:r>
+              <a:rPr sz="1200">
+                <a:solidFill>
+                  <a:srgbClr val="C2D0DA"/>
+                </a:solidFill>
+                <a:latin typeface="Consolas"/>
+              </a:rPr>
+              <a:t> } },</a:t>
             </a:r>
           </a:p>
           <a:p>
@@ -11170,7 +12026,7 @@
                 </a:solidFill>
                 <a:latin typeface="Consolas"/>
               </a:rPr>
-              <a:t>    </a:t>
+              <a:t>  </a:t>
             </a:r>
             <a:r>
               <a:rPr sz="1200">
@@ -11179,7 +12035,25 @@
                 </a:solidFill>
                 <a:latin typeface="Consolas"/>
               </a:rPr>
-              <a:t>"name"</a:t>
+              <a:t>"trs"</a:t>
+            </a:r>
+            <a:r>
+              <a:rPr sz="1200">
+                <a:solidFill>
+                  <a:srgbClr val="C2D0DA"/>
+                </a:solidFill>
+                <a:latin typeface="Consolas"/>
+              </a:rPr>
+              <a:t>: { </a:t>
+            </a:r>
+            <a:r>
+              <a:rPr sz="1200">
+                <a:solidFill>
+                  <a:srgbClr val="6FC3E0"/>
+                </a:solidFill>
+                <a:latin typeface="Consolas"/>
+              </a:rPr>
+              <a:t>"type"</a:t>
             </a:r>
             <a:r>
               <a:rPr sz="1200">
@@ -11197,7 +12071,16 @@
                 </a:solidFill>
                 <a:latin typeface="Consolas"/>
               </a:rPr>
-              <a:t>"vessel 111219510"</a:t>
+              <a:t>"Link"</a:t>
+            </a:r>
+            <a:r>
+              <a:rPr sz="1200">
+                <a:solidFill>
+                  <a:srgbClr val="C2D0DA"/>
+                </a:solidFill>
+                <a:latin typeface="Consolas"/>
+              </a:rPr>
+              <a:t>,</a:t>
             </a:r>
           </a:p>
           <a:p>
@@ -11219,7 +12102,61 @@
                 </a:solidFill>
                 <a:latin typeface="Consolas"/>
               </a:rPr>
-              <a:t>  },</a:t>
+              <a:t>           </a:t>
+            </a:r>
+            <a:r>
+              <a:rPr sz="1200">
+                <a:solidFill>
+                  <a:srgbClr val="6FC3E0"/>
+                </a:solidFill>
+                <a:latin typeface="Consolas"/>
+              </a:rPr>
+              <a:t>"properties"</a:t>
+            </a:r>
+            <a:r>
+              <a:rPr sz="1200">
+                <a:solidFill>
+                  <a:srgbClr val="C2D0DA"/>
+                </a:solidFill>
+                <a:latin typeface="Consolas"/>
+              </a:rPr>
+              <a:t>: { </a:t>
+            </a:r>
+            <a:r>
+              <a:rPr sz="1200">
+                <a:solidFill>
+                  <a:srgbClr val="6FC3E0"/>
+                </a:solidFill>
+                <a:latin typeface="Consolas"/>
+              </a:rPr>
+              <a:t>"type"</a:t>
+            </a:r>
+            <a:r>
+              <a:rPr sz="1200">
+                <a:solidFill>
+                  <a:srgbClr val="C2D0DA"/>
+                </a:solidFill>
+                <a:latin typeface="Consolas"/>
+              </a:rPr>
+              <a:t>: </a:t>
+            </a:r>
+            <a:r>
+              <a:rPr sz="1200">
+                <a:solidFill>
+                  <a:srgbClr val="E6A36A"/>
+                </a:solidFill>
+                <a:latin typeface="Consolas"/>
+              </a:rPr>
+              <a:t>"ogcdef"</a:t>
+            </a:r>
+            <a:r>
+              <a:rPr sz="1200">
+                <a:solidFill>
+                  <a:srgbClr val="C2D0DA"/>
+                </a:solidFill>
+                <a:latin typeface="Consolas"/>
+              </a:rPr>
+              <a:t>,</a:t>
             </a:r>
           </a:p>
           <a:p>
@@ -11241,7 +12178,7 @@
                 </a:solidFill>
                 <a:latin typeface="Consolas"/>
               </a:rPr>
-              <a:t>  </a:t>
+              <a:t>             </a:t>
             </a:r>
             <a:r>
               <a:rPr sz="1200">
@@ -11250,16 +12187,34 @@
                 </a:solidFill>
                 <a:latin typeface="Consolas"/>
               </a:rPr>
-              <a:t>"temporalGeometry"</a:t>
-            </a:r>
-            <a:r>
-              <a:rPr sz="1200">
-                <a:solidFill>
-                  <a:srgbClr val="C2D0DA"/>
-                </a:solidFill>
-                <a:latin typeface="Consolas"/>
-              </a:rPr>
-              <a:t>: {</a:t>
+              <a:t>"href"</a:t>
+            </a:r>
+            <a:r>
+              <a:rPr sz="1200">
+                <a:solidFill>
+                  <a:srgbClr val="C2D0DA"/>
+                </a:solidFill>
+                <a:latin typeface="Consolas"/>
+              </a:rPr>
+              <a:t>: </a:t>
+            </a:r>
+            <a:r>
+              <a:rPr sz="1200">
+                <a:solidFill>
+                  <a:srgbClr val="E6A36A"/>
+                </a:solidFill>
+                <a:latin typeface="Consolas"/>
+              </a:rPr>
+              <a:t>".../uom/ISO-8601/0/Gregorian"</a:t>
+            </a:r>
+            <a:r>
+              <a:rPr sz="1200">
+                <a:solidFill>
+                  <a:srgbClr val="C2D0DA"/>
+                </a:solidFill>
+                <a:latin typeface="Consolas"/>
+              </a:rPr>
+              <a:t> } },</a:t>
             </a:r>
           </a:p>
           <a:p>
@@ -11281,7 +12236,7 @@
                 </a:solidFill>
                 <a:latin typeface="Consolas"/>
               </a:rPr>
-              <a:t>    </a:t>
+              <a:t>  </a:t>
             </a:r>
             <a:r>
               <a:rPr sz="1200">
@@ -11290,34 +12245,88 @@
                 </a:solidFill>
                 <a:latin typeface="Consolas"/>
               </a:rPr>
-              <a:t>"type"</a:t>
-            </a:r>
-            <a:r>
-              <a:rPr sz="1200">
-                <a:solidFill>
-                  <a:srgbClr val="C2D0DA"/>
-                </a:solidFill>
-                <a:latin typeface="Consolas"/>
-              </a:rPr>
-              <a:t>: </a:t>
-            </a:r>
-            <a:r>
-              <a:rPr sz="1200">
-                <a:solidFill>
-                  <a:srgbClr val="E6A36A"/>
-                </a:solidFill>
-                <a:latin typeface="Consolas"/>
-              </a:rPr>
-              <a:t>"MovingPoint"</a:t>
-            </a:r>
-            <a:r>
-              <a:rPr sz="1200">
-                <a:solidFill>
-                  <a:srgbClr val="C2D0DA"/>
-                </a:solidFill>
-                <a:latin typeface="Consolas"/>
-              </a:rPr>
-              <a:t>,</a:t>
+              <a:t>"bbox"</a:t>
+            </a:r>
+            <a:r>
+              <a:rPr sz="1200">
+                <a:solidFill>
+                  <a:srgbClr val="C2D0DA"/>
+                </a:solidFill>
+                <a:latin typeface="Consolas"/>
+              </a:rPr>
+              <a:t>: [</a:t>
+            </a:r>
+            <a:r>
+              <a:rPr sz="1200">
+                <a:solidFill>
+                  <a:srgbClr val="C9E08A"/>
+                </a:solidFill>
+                <a:latin typeface="Consolas"/>
+              </a:rPr>
+              <a:t>550889</a:t>
+            </a:r>
+            <a:r>
+              <a:rPr sz="1200">
+                <a:solidFill>
+                  <a:srgbClr val="C2D0DA"/>
+                </a:solidFill>
+                <a:latin typeface="Consolas"/>
+              </a:rPr>
+              <a:t>, </a:t>
+            </a:r>
+            <a:r>
+              <a:rPr sz="1200">
+                <a:solidFill>
+                  <a:srgbClr val="C9E08A"/>
+                </a:solidFill>
+                <a:latin typeface="Consolas"/>
+              </a:rPr>
+              <a:t>6328752</a:t>
+            </a:r>
+            <a:r>
+              <a:rPr sz="1200">
+                <a:solidFill>
+                  <a:srgbClr val="C2D0DA"/>
+                </a:solidFill>
+                <a:latin typeface="Consolas"/>
+              </a:rPr>
+              <a:t>, </a:t>
+            </a:r>
+            <a:r>
+              <a:rPr sz="1200">
+                <a:solidFill>
+                  <a:srgbClr val="C9E08A"/>
+                </a:solidFill>
+                <a:latin typeface="Consolas"/>
+              </a:rPr>
+              <a:t>616716</a:t>
+            </a:r>
+            <a:r>
+              <a:rPr sz="1200">
+                <a:solidFill>
+                  <a:srgbClr val="C2D0DA"/>
+                </a:solidFill>
+                <a:latin typeface="Consolas"/>
+              </a:rPr>
+              <a:t>, </a:t>
+            </a:r>
+            <a:r>
+              <a:rPr sz="1200">
+                <a:solidFill>
+                  <a:srgbClr val="C9E08A"/>
+                </a:solidFill>
+                <a:latin typeface="Consolas"/>
+              </a:rPr>
+              <a:t>6346258</a:t>
+            </a:r>
+            <a:r>
+              <a:rPr sz="1200">
+                <a:solidFill>
+                  <a:srgbClr val="C2D0DA"/>
+                </a:solidFill>
+                <a:latin typeface="Consolas"/>
+              </a:rPr>
+              <a:t>],</a:t>
             </a:r>
           </a:p>
           <a:p>
@@ -11339,7 +12348,7 @@
                 </a:solidFill>
                 <a:latin typeface="Consolas"/>
               </a:rPr>
-              <a:t>    </a:t>
+              <a:t>  </a:t>
             </a:r>
             <a:r>
               <a:rPr sz="1200">
@@ -11348,34 +12357,16 @@
                 </a:solidFill>
                 <a:latin typeface="Consolas"/>
               </a:rPr>
-              <a:t>"crs"</a:t>
-            </a:r>
-            <a:r>
-              <a:rPr sz="1200">
-                <a:solidFill>
-                  <a:srgbClr val="C2D0DA"/>
-                </a:solidFill>
-                <a:latin typeface="Consolas"/>
-              </a:rPr>
-              <a:t>: { </a:t>
-            </a:r>
-            <a:r>
-              <a:rPr sz="1200">
-                <a:solidFill>
-                  <a:srgbClr val="6FC3E0"/>
-                </a:solidFill>
-                <a:latin typeface="Consolas"/>
-              </a:rPr>
-              <a:t>"type"</a:t>
-            </a:r>
-            <a:r>
-              <a:rPr sz="1200">
-                <a:solidFill>
-                  <a:srgbClr val="C2D0DA"/>
-                </a:solidFill>
-                <a:latin typeface="Consolas"/>
-              </a:rPr>
-              <a:t>: </a:t>
+              <a:t>"time"</a:t>
+            </a:r>
+            <a:r>
+              <a:rPr sz="1200">
+                <a:solidFill>
+                  <a:srgbClr val="C2D0DA"/>
+                </a:solidFill>
+                <a:latin typeface="Consolas"/>
+              </a:rPr>
+              <a:t>: [</a:t>
             </a:r>
             <a:r>
               <a:rPr sz="1200">
@@ -11384,7 +12375,7 @@
                 </a:solidFill>
                 <a:latin typeface="Consolas"/>
               </a:rPr>
-              <a:t>"Name"</a:t>
+              <a:t>"2026-02-26 13:28:08+01"</a:t>
             </a:r>
             <a:r>
               <a:rPr sz="1200">
@@ -11398,20 +12389,20 @@
             <a:r>
               <a:rPr sz="1200">
                 <a:solidFill>
-                  <a:srgbClr val="6FC3E0"/>
-                </a:solidFill>
-                <a:latin typeface="Consolas"/>
-              </a:rPr>
-              <a:t>"properties"</a:t>
-            </a:r>
-            <a:r>
-              <a:rPr sz="1200">
-                <a:solidFill>
-                  <a:srgbClr val="C2D0DA"/>
-                </a:solidFill>
-                <a:latin typeface="Consolas"/>
-              </a:rPr>
-              <a:t>: {</a:t>
+                  <a:srgbClr val="E6A36A"/>
+                </a:solidFill>
+                <a:latin typeface="Consolas"/>
+              </a:rPr>
+              <a:t>"2026-02-26 14:41:04+01"</a:t>
+            </a:r>
+            <a:r>
+              <a:rPr sz="1200">
+                <a:solidFill>
+                  <a:srgbClr val="C2D0DA"/>
+                </a:solidFill>
+                <a:latin typeface="Consolas"/>
+              </a:rPr>
+              <a:t>],</a:t>
             </a:r>
           </a:p>
           <a:p>
@@ -11433,7 +12424,7 @@
                 </a:solidFill>
                 <a:latin typeface="Consolas"/>
               </a:rPr>
-              <a:t>      </a:t>
+              <a:t>  </a:t>
             </a:r>
             <a:r>
               <a:rPr sz="1200">
@@ -11442,7 +12433,25 @@
                 </a:solidFill>
                 <a:latin typeface="Consolas"/>
               </a:rPr>
-              <a:t>"name"</a:t>
+              <a:t>"geometry"</a:t>
+            </a:r>
+            <a:r>
+              <a:rPr sz="1200">
+                <a:solidFill>
+                  <a:srgbClr val="C2D0DA"/>
+                </a:solidFill>
+                <a:latin typeface="Consolas"/>
+              </a:rPr>
+              <a:t>: { </a:t>
+            </a:r>
+            <a:r>
+              <a:rPr sz="1200">
+                <a:solidFill>
+                  <a:srgbClr val="6FC3E0"/>
+                </a:solidFill>
+                <a:latin typeface="Consolas"/>
+              </a:rPr>
+              <a:t>"type"</a:t>
             </a:r>
             <a:r>
               <a:rPr sz="1200">
@@ -11460,16 +12469,34 @@
                 </a:solidFill>
                 <a:latin typeface="Consolas"/>
               </a:rPr>
-              <a:t>"urn:ogc:def:crs:EPSG::25832"</a:t>
-            </a:r>
-            <a:r>
-              <a:rPr sz="1200">
-                <a:solidFill>
-                  <a:srgbClr val="C2D0DA"/>
-                </a:solidFill>
-                <a:latin typeface="Consolas"/>
-              </a:rPr>
-              <a:t> } },</a:t>
+              <a:t>"MultiLineString"</a:t>
+            </a:r>
+            <a:r>
+              <a:rPr sz="1200">
+                <a:solidFill>
+                  <a:srgbClr val="C2D0DA"/>
+                </a:solidFill>
+                <a:latin typeface="Consolas"/>
+              </a:rPr>
+              <a:t>, </a:t>
+            </a:r>
+            <a:r>
+              <a:rPr sz="1200">
+                <a:solidFill>
+                  <a:srgbClr val="6FC3E0"/>
+                </a:solidFill>
+                <a:latin typeface="Consolas"/>
+              </a:rPr>
+              <a:t>"coordinates"</a:t>
+            </a:r>
+            <a:r>
+              <a:rPr sz="1200">
+                <a:solidFill>
+                  <a:srgbClr val="C2D0DA"/>
+                </a:solidFill>
+                <a:latin typeface="Consolas"/>
+              </a:rPr>
+              <a:t>: [...] },</a:t>
             </a:r>
           </a:p>
           <a:p>
@@ -11491,7 +12518,7 @@
                 </a:solidFill>
                 <a:latin typeface="Consolas"/>
               </a:rPr>
-              <a:t>    </a:t>
+              <a:t>  </a:t>
             </a:r>
             <a:r>
               <a:rPr sz="1200">
@@ -11500,16 +12527,16 @@
                 </a:solidFill>
                 <a:latin typeface="Consolas"/>
               </a:rPr>
-              <a:t>"sequences"</a:t>
-            </a:r>
-            <a:r>
-              <a:rPr sz="1200">
-                <a:solidFill>
-                  <a:srgbClr val="C2D0DA"/>
-                </a:solidFill>
-                <a:latin typeface="Consolas"/>
-              </a:rPr>
-              <a:t>: [</a:t>
+              <a:t>"temporalGeometry"</a:t>
+            </a:r>
+            <a:r>
+              <a:rPr sz="1200">
+                <a:solidFill>
+                  <a:srgbClr val="C2D0DA"/>
+                </a:solidFill>
+                <a:latin typeface="Consolas"/>
+              </a:rPr>
+              <a:t>: {</a:t>
             </a:r>
           </a:p>
           <a:p>
@@ -11531,7 +12558,7 @@
                 </a:solidFill>
                 <a:latin typeface="Consolas"/>
               </a:rPr>
-              <a:t>      { </a:t>
+              <a:t>    </a:t>
             </a:r>
             <a:r>
               <a:rPr sz="1200">
@@ -11540,16 +12567,16 @@
                 </a:solidFill>
                 <a:latin typeface="Consolas"/>
               </a:rPr>
-              <a:t>"datetimes"</a:t>
-            </a:r>
-            <a:r>
-              <a:rPr sz="1200">
-                <a:solidFill>
-                  <a:srgbClr val="C2D0DA"/>
-                </a:solidFill>
-                <a:latin typeface="Consolas"/>
-              </a:rPr>
-              <a:t>: [</a:t>
+              <a:t>"type"</a:t>
+            </a:r>
+            <a:r>
+              <a:rPr sz="1200">
+                <a:solidFill>
+                  <a:srgbClr val="C2D0DA"/>
+                </a:solidFill>
+                <a:latin typeface="Consolas"/>
+              </a:rPr>
+              <a:t>: </a:t>
             </a:r>
             <a:r>
               <a:rPr sz="1200">
@@ -11558,16 +12585,16 @@
                 </a:solidFill>
                 <a:latin typeface="Consolas"/>
               </a:rPr>
-              <a:t>"2026-02-26T13:28:08+01"</a:t>
-            </a:r>
-            <a:r>
-              <a:rPr sz="1200">
-                <a:solidFill>
-                  <a:srgbClr val="C2D0DA"/>
-                </a:solidFill>
-                <a:latin typeface="Consolas"/>
-              </a:rPr>
-              <a:t>, ...],</a:t>
+              <a:t>"MovingPoint"</a:t>
+            </a:r>
+            <a:r>
+              <a:rPr sz="1200">
+                <a:solidFill>
+                  <a:srgbClr val="C2D0DA"/>
+                </a:solidFill>
+                <a:latin typeface="Consolas"/>
+              </a:rPr>
+              <a:t>,</a:t>
             </a:r>
           </a:p>
           <a:p>
@@ -11589,7 +12616,7 @@
                 </a:solidFill>
                 <a:latin typeface="Consolas"/>
               </a:rPr>
-              <a:t>        </a:t>
+              <a:t>    </a:t>
             </a:r>
             <a:r>
               <a:rPr sz="1200">
@@ -11598,6 +12625,42 @@
                 </a:solidFill>
                 <a:latin typeface="Consolas"/>
               </a:rPr>
+              <a:t>"sequences"</a:t>
+            </a:r>
+            <a:r>
+              <a:rPr sz="1200">
+                <a:solidFill>
+                  <a:srgbClr val="C2D0DA"/>
+                </a:solidFill>
+                <a:latin typeface="Consolas"/>
+              </a:rPr>
+              <a:t>: [ { </a:t>
+            </a:r>
+            <a:r>
+              <a:rPr sz="1200">
+                <a:solidFill>
+                  <a:srgbClr val="6FC3E0"/>
+                </a:solidFill>
+                <a:latin typeface="Consolas"/>
+              </a:rPr>
+              <a:t>"datetimes"</a:t>
+            </a:r>
+            <a:r>
+              <a:rPr sz="1200">
+                <a:solidFill>
+                  <a:srgbClr val="C2D0DA"/>
+                </a:solidFill>
+                <a:latin typeface="Consolas"/>
+              </a:rPr>
+              <a:t>: [...], </a:t>
+            </a:r>
+            <a:r>
+              <a:rPr sz="1200">
+                <a:solidFill>
+                  <a:srgbClr val="6FC3E0"/>
+                </a:solidFill>
+                <a:latin typeface="Consolas"/>
+              </a:rPr>
               <a:t>"coordinates"</a:t>
             </a:r>
             <a:r>
@@ -11607,43 +12670,7 @@
                 </a:solidFill>
                 <a:latin typeface="Consolas"/>
               </a:rPr>
-              <a:t>: [[</a:t>
-            </a:r>
-            <a:r>
-              <a:rPr sz="1200">
-                <a:solidFill>
-                  <a:srgbClr val="C9E08A"/>
-                </a:solidFill>
-                <a:latin typeface="Consolas"/>
-              </a:rPr>
-              <a:t>721000.4</a:t>
-            </a:r>
-            <a:r>
-              <a:rPr sz="1200">
-                <a:solidFill>
-                  <a:srgbClr val="C2D0DA"/>
-                </a:solidFill>
-                <a:latin typeface="Consolas"/>
-              </a:rPr>
-              <a:t>, </a:t>
-            </a:r>
-            <a:r>
-              <a:rPr sz="1200">
-                <a:solidFill>
-                  <a:srgbClr val="C9E08A"/>
-                </a:solidFill>
-                <a:latin typeface="Consolas"/>
-              </a:rPr>
-              <a:t>6178001.2</a:t>
-            </a:r>
-            <a:r>
-              <a:rPr sz="1200">
-                <a:solidFill>
-                  <a:srgbClr val="C2D0DA"/>
-                </a:solidFill>
-                <a:latin typeface="Consolas"/>
-              </a:rPr>
-              <a:t>], ...] } ],</a:t>
+              <a:t>: [...] } ],</a:t>
             </a:r>
           </a:p>
           <a:p>
@@ -11694,6 +12721,15 @@
               </a:rPr>
               <a:t>"Linear"</a:t>
             </a:r>
+            <a:r>
+              <a:rPr sz="1200">
+                <a:solidFill>
+                  <a:srgbClr val="C2D0DA"/>
+                </a:solidFill>
+                <a:latin typeface="Consolas"/>
+              </a:rPr>
+              <a:t> },</a:t>
+            </a:r>
           </a:p>
           <a:p>
             <a:pPr>
@@ -11714,7 +12750,61 @@
                 </a:solidFill>
                 <a:latin typeface="Consolas"/>
               </a:rPr>
-              <a:t>  }</a:t>
+              <a:t>  </a:t>
+            </a:r>
+            <a:r>
+              <a:rPr sz="1200">
+                <a:solidFill>
+                  <a:srgbClr val="6FC3E0"/>
+                </a:solidFill>
+                <a:latin typeface="Consolas"/>
+              </a:rPr>
+              <a:t>"links"</a:t>
+            </a:r>
+            <a:r>
+              <a:rPr sz="1200">
+                <a:solidFill>
+                  <a:srgbClr val="C2D0DA"/>
+                </a:solidFill>
+                <a:latin typeface="Consolas"/>
+              </a:rPr>
+              <a:t>: [ { </a:t>
+            </a:r>
+            <a:r>
+              <a:rPr sz="1200">
+                <a:solidFill>
+                  <a:srgbClr val="6FC3E0"/>
+                </a:solidFill>
+                <a:latin typeface="Consolas"/>
+              </a:rPr>
+              <a:t>"rel"</a:t>
+            </a:r>
+            <a:r>
+              <a:rPr sz="1200">
+                <a:solidFill>
+                  <a:srgbClr val="C2D0DA"/>
+                </a:solidFill>
+                <a:latin typeface="Consolas"/>
+              </a:rPr>
+              <a:t>: </a:t>
+            </a:r>
+            <a:r>
+              <a:rPr sz="1200">
+                <a:solidFill>
+                  <a:srgbClr val="E6A36A"/>
+                </a:solidFill>
+                <a:latin typeface="Consolas"/>
+              </a:rPr>
+              <a:t>"self"</a:t>
+            </a:r>
+            <a:r>
+              <a:rPr sz="1200">
+                <a:solidFill>
+                  <a:srgbClr val="C2D0DA"/>
+                </a:solidFill>
+                <a:latin typeface="Consolas"/>
+              </a:rPr>
+              <a:t>,</a:t>
             </a:r>
           </a:p>
           <a:p>
@@ -11736,6 +12826,64 @@
                 </a:solidFill>
                 <a:latin typeface="Consolas"/>
               </a:rPr>
+              <a:t>               </a:t>
+            </a:r>
+            <a:r>
+              <a:rPr sz="1200">
+                <a:solidFill>
+                  <a:srgbClr val="6FC3E0"/>
+                </a:solidFill>
+                <a:latin typeface="Consolas"/>
+              </a:rPr>
+              <a:t>"href"</a:t>
+            </a:r>
+            <a:r>
+              <a:rPr sz="1200">
+                <a:solidFill>
+                  <a:srgbClr val="C2D0DA"/>
+                </a:solidFill>
+                <a:latin typeface="Consolas"/>
+              </a:rPr>
+              <a:t>: </a:t>
+            </a:r>
+            <a:r>
+              <a:rPr sz="1200">
+                <a:solidFill>
+                  <a:srgbClr val="E6A36A"/>
+                </a:solidFill>
+                <a:latin typeface="Consolas"/>
+              </a:rPr>
+              <a:t>"/collections/ships/items/1"</a:t>
+            </a:r>
+            <a:r>
+              <a:rPr sz="1200">
+                <a:solidFill>
+                  <a:srgbClr val="C2D0DA"/>
+                </a:solidFill>
+                <a:latin typeface="Consolas"/>
+              </a:rPr>
+              <a:t> } ]</a:t>
+            </a:r>
+          </a:p>
+          <a:p>
+            <a:pPr>
+              <a:lnSpc>
+                <a:spcPct val="102000"/>
+              </a:lnSpc>
+              <a:spcBef>
+                <a:spcPts val="0"/>
+              </a:spcBef>
+              <a:spcAft>
+                <a:spcPts val="0"/>
+              </a:spcAft>
+            </a:pPr>
+            <a:r>
+              <a:rPr sz="1200">
+                <a:solidFill>
+                  <a:srgbClr val="C2D0DA"/>
+                </a:solidFill>
+                <a:latin typeface="Consolas"/>
+              </a:rPr>
               <a:t>}</a:t>
             </a:r>
           </a:p>
@@ -11749,8 +12897,8 @@
         </p:nvSpPr>
         <p:spPr>
           <a:xfrm>
-            <a:off x="6830568" y="1828800"/>
-            <a:ext cx="4794199" cy="4206240"/>
+            <a:off x="7424927" y="1828800"/>
+            <a:ext cx="4199839" cy="4206240"/>
           </a:xfrm>
           <a:prstGeom prst="rect">
             <a:avLst/>
@@ -11771,7 +12919,7 @@
                 <a:spcPts val="0"/>
               </a:spcBef>
               <a:spcAft>
-                <a:spcPts val="1300"/>
+                <a:spcPts val="1200"/>
               </a:spcAft>
             </a:pPr>
             <a:r>
@@ -11811,7 +12959,7 @@
                 <a:spcPts val="0"/>
               </a:spcBef>
               <a:spcAft>
-                <a:spcPts val="1300"/>
+                <a:spcPts val="1200"/>
               </a:spcAft>
             </a:pPr>
             <a:r>
@@ -11851,7 +12999,7 @@
                 <a:spcPts val="0"/>
               </a:spcBef>
               <a:spcAft>
-                <a:spcPts val="1300"/>
+                <a:spcPts val="1200"/>
               </a:spcAft>
             </a:pPr>
             <a:r>
@@ -11891,7 +13039,7 @@
                 <a:spcPts val="0"/>
               </a:spcBef>
               <a:spcAft>
-                <a:spcPts val="1300"/>
+                <a:spcPts val="1200"/>
               </a:spcAft>
             </a:pPr>
             <a:r>
@@ -19087,13 +20235,13 @@
           </a:xfrm>
           <a:prstGeom prst="roundRect">
             <a:avLst>
-              <a:gd name="adj" fmla="val 16000"/>
+              <a:gd name="adj" fmla="val 12000"/>
             </a:avLst>
           </a:prstGeom>
           <a:solidFill>
             <a:srgbClr val="FFFFFF"/>
           </a:solidFill>
-          <a:ln w="16510">
+          <a:ln w="19050">
             <a:solidFill>
               <a:srgbClr val="0E2841"/>
             </a:solidFill>
@@ -19177,13 +20325,13 @@
           </a:xfrm>
           <a:prstGeom prst="roundRect">
             <a:avLst>
-              <a:gd name="adj" fmla="val 16000"/>
+              <a:gd name="adj" fmla="val 12000"/>
             </a:avLst>
           </a:prstGeom>
           <a:solidFill>
             <a:srgbClr val="FFFFFF"/>
           </a:solidFill>
-          <a:ln w="16510">
+          <a:ln w="19050">
             <a:solidFill>
               <a:srgbClr val="0E2841"/>
             </a:solidFill>
@@ -19267,13 +20415,13 @@
           </a:xfrm>
           <a:prstGeom prst="roundRect">
             <a:avLst>
-              <a:gd name="adj" fmla="val 16000"/>
+              <a:gd name="adj" fmla="val 12000"/>
             </a:avLst>
           </a:prstGeom>
           <a:solidFill>
             <a:srgbClr val="FFFFFF"/>
           </a:solidFill>
-          <a:ln w="16510">
+          <a:ln w="19050">
             <a:solidFill>
               <a:srgbClr val="0E2841"/>
             </a:solidFill>
@@ -19441,13 +20589,13 @@
           </a:xfrm>
           <a:prstGeom prst="roundRect">
             <a:avLst>
-              <a:gd name="adj" fmla="val 10000"/>
+              <a:gd name="adj" fmla="val 12000"/>
             </a:avLst>
           </a:prstGeom>
           <a:solidFill>
             <a:srgbClr val="FFFFFF"/>
           </a:solidFill>
-          <a:ln w="21590">
+          <a:ln w="19050">
             <a:solidFill>
               <a:srgbClr val="156082"/>
             </a:solidFill>
@@ -19657,13 +20805,13 @@
           </a:xfrm>
           <a:prstGeom prst="roundRect">
             <a:avLst>
-              <a:gd name="adj" fmla="val 10000"/>
+              <a:gd name="adj" fmla="val 12000"/>
             </a:avLst>
           </a:prstGeom>
           <a:solidFill>
             <a:srgbClr val="FFFFFF"/>
           </a:solidFill>
-          <a:ln w="21590">
+          <a:ln w="19050">
             <a:solidFill>
               <a:srgbClr val="0E2841"/>
             </a:solidFill>

</xml_diff>

<commit_message>
V5 deck: uniform flat borders on the slide-2 tier diagram
All client, API and database boxes (and the container) share one border colour,
width and corner radius, and the inherited drop shadow is removed so the boxes
read as a single uniform style.
</commit_message>
<xml_diff>
--- a/MobilityAPIV5.pptx
+++ b/MobilityAPIV5.pptx
@@ -20158,20 +20158,6 @@
           </a:ln>
           <a:effectLst/>
         </p:spPr>
-        <p:style>
-          <a:lnRef idx="1">
-            <a:schemeClr val="accent1"/>
-          </a:lnRef>
-          <a:fillRef idx="3">
-            <a:schemeClr val="accent1"/>
-          </a:fillRef>
-          <a:effectRef idx="2">
-            <a:schemeClr val="accent1"/>
-          </a:effectRef>
-          <a:fontRef idx="minor">
-            <a:schemeClr val="lt1"/>
-          </a:fontRef>
-        </p:style>
         <p:txBody>
           <a:bodyPr rtlCol="0" anchor="ctr"/>
           <a:lstStyle/>
@@ -20248,20 +20234,6 @@
           </a:ln>
           <a:effectLst/>
         </p:spPr>
-        <p:style>
-          <a:lnRef idx="1">
-            <a:schemeClr val="accent1"/>
-          </a:lnRef>
-          <a:fillRef idx="3">
-            <a:schemeClr val="accent1"/>
-          </a:fillRef>
-          <a:effectRef idx="2">
-            <a:schemeClr val="accent1"/>
-          </a:effectRef>
-          <a:fontRef idx="minor">
-            <a:schemeClr val="lt1"/>
-          </a:fontRef>
-        </p:style>
         <p:txBody>
           <a:bodyPr rtlCol="0" anchor="ctr"/>
           <a:lstStyle/>
@@ -20338,20 +20310,6 @@
           </a:ln>
           <a:effectLst/>
         </p:spPr>
-        <p:style>
-          <a:lnRef idx="1">
-            <a:schemeClr val="accent1"/>
-          </a:lnRef>
-          <a:fillRef idx="3">
-            <a:schemeClr val="accent1"/>
-          </a:fillRef>
-          <a:effectRef idx="2">
-            <a:schemeClr val="accent1"/>
-          </a:effectRef>
-          <a:fontRef idx="minor">
-            <a:schemeClr val="lt1"/>
-          </a:fontRef>
-        </p:style>
         <p:txBody>
           <a:bodyPr rtlCol="0" anchor="ctr"/>
           <a:lstStyle/>
@@ -20428,20 +20386,6 @@
           </a:ln>
           <a:effectLst/>
         </p:spPr>
-        <p:style>
-          <a:lnRef idx="1">
-            <a:schemeClr val="accent1"/>
-          </a:lnRef>
-          <a:fillRef idx="3">
-            <a:schemeClr val="accent1"/>
-          </a:fillRef>
-          <a:effectRef idx="2">
-            <a:schemeClr val="accent1"/>
-          </a:effectRef>
-          <a:fontRef idx="minor">
-            <a:schemeClr val="lt1"/>
-          </a:fontRef>
-        </p:style>
         <p:txBody>
           <a:bodyPr rtlCol="0" anchor="ctr"/>
           <a:lstStyle/>
@@ -20586,222 +20530,6 @@
           <a:xfrm>
             <a:off x="7909560" y="3108960"/>
             <a:ext cx="3429000" cy="603504"/>
-          </a:xfrm>
-          <a:prstGeom prst="roundRect">
-            <a:avLst>
-              <a:gd name="adj" fmla="val 12000"/>
-            </a:avLst>
-          </a:prstGeom>
-          <a:solidFill>
-            <a:srgbClr val="FFFFFF"/>
-          </a:solidFill>
-          <a:ln w="19050">
-            <a:solidFill>
-              <a:srgbClr val="156082"/>
-            </a:solidFill>
-          </a:ln>
-          <a:effectLst/>
-        </p:spPr>
-        <p:style>
-          <a:lnRef idx="1">
-            <a:schemeClr val="accent1"/>
-          </a:lnRef>
-          <a:fillRef idx="3">
-            <a:schemeClr val="accent1"/>
-          </a:fillRef>
-          <a:effectRef idx="2">
-            <a:schemeClr val="accent1"/>
-          </a:effectRef>
-          <a:fontRef idx="minor">
-            <a:schemeClr val="lt1"/>
-          </a:fontRef>
-        </p:style>
-        <p:txBody>
-          <a:bodyPr rtlCol="0" anchor="ctr"/>
-          <a:lstStyle/>
-          <a:p>
-            <a:pPr algn="ctr"/>
-          </a:p>
-        </p:txBody>
-      </p:sp>
-      <p:sp>
-        <p:nvSpPr>
-          <p:cNvPr id="17" name="TextBox 16"/>
-          <p:cNvSpPr txBox="1"/>
-          <p:nvPr/>
-        </p:nvSpPr>
-        <p:spPr>
-          <a:xfrm>
-            <a:off x="8092440" y="3191256"/>
-            <a:ext cx="3063240" cy="274320"/>
-          </a:xfrm>
-          <a:prstGeom prst="rect">
-            <a:avLst/>
-          </a:prstGeom>
-          <a:noFill/>
-        </p:spPr>
-        <p:txBody>
-          <a:bodyPr wrap="square" anchor="t" lIns="0" rIns="0" tIns="0" bIns="0">
-            <a:noAutofit/>
-          </a:bodyPr>
-          <a:lstStyle/>
-          <a:p>
-            <a:pPr algn="l">
-              <a:spcBef>
-                <a:spcPts val="0"/>
-              </a:spcBef>
-              <a:spcAft>
-                <a:spcPts val="200"/>
-              </a:spcAft>
-            </a:pPr>
-            <a:r>
-              <a:rPr sz="1400" b="1" i="0">
-                <a:solidFill>
-                  <a:srgbClr val="156082"/>
-                </a:solidFill>
-                <a:latin typeface="Calibri"/>
-              </a:rPr>
-              <a:t>MobilityAPI (Go)</a:t>
-            </a:r>
-          </a:p>
-        </p:txBody>
-      </p:sp>
-      <p:sp>
-        <p:nvSpPr>
-          <p:cNvPr id="18" name="TextBox 17"/>
-          <p:cNvSpPr txBox="1"/>
-          <p:nvPr/>
-        </p:nvSpPr>
-        <p:spPr>
-          <a:xfrm>
-            <a:off x="8092440" y="3456432"/>
-            <a:ext cx="3063240" cy="228600"/>
-          </a:xfrm>
-          <a:prstGeom prst="rect">
-            <a:avLst/>
-          </a:prstGeom>
-          <a:noFill/>
-        </p:spPr>
-        <p:txBody>
-          <a:bodyPr wrap="square" anchor="t" lIns="0" rIns="0" tIns="0" bIns="0">
-            <a:noAutofit/>
-          </a:bodyPr>
-          <a:lstStyle/>
-          <a:p>
-            <a:pPr algn="l">
-              <a:spcBef>
-                <a:spcPts val="0"/>
-              </a:spcBef>
-              <a:spcAft>
-                <a:spcPts val="200"/>
-              </a:spcAft>
-            </a:pPr>
-            <a:r>
-              <a:rPr sz="1200" b="0" i="0">
-                <a:solidFill>
-                  <a:srgbClr val="5B6B78"/>
-                </a:solidFill>
-                <a:latin typeface="Consolas"/>
-              </a:rPr>
-              <a:t>net/http + pgxpool</a:t>
-            </a:r>
-          </a:p>
-        </p:txBody>
-      </p:sp>
-      <p:sp>
-        <p:nvSpPr>
-          <p:cNvPr id="19" name="TextBox 18"/>
-          <p:cNvSpPr txBox="1"/>
-          <p:nvPr/>
-        </p:nvSpPr>
-        <p:spPr>
-          <a:xfrm>
-            <a:off x="7909560" y="3749040"/>
-            <a:ext cx="3429000" cy="219456"/>
-          </a:xfrm>
-          <a:prstGeom prst="rect">
-            <a:avLst/>
-          </a:prstGeom>
-          <a:noFill/>
-        </p:spPr>
-        <p:txBody>
-          <a:bodyPr wrap="square" anchor="t" lIns="0" rIns="0" tIns="0" bIns="0">
-            <a:noAutofit/>
-          </a:bodyPr>
-          <a:lstStyle/>
-          <a:p>
-            <a:pPr algn="ctr">
-              <a:spcBef>
-                <a:spcPts val="0"/>
-              </a:spcBef>
-              <a:spcAft>
-                <a:spcPts val="200"/>
-              </a:spcAft>
-            </a:pPr>
-            <a:r>
-              <a:rPr sz="1200" b="1" i="0">
-                <a:solidFill>
-                  <a:srgbClr val="E97132"/>
-                </a:solidFill>
-                <a:latin typeface="Calibri"/>
-              </a:rPr>
-              <a:t>▼  SQL</a:t>
-            </a:r>
-          </a:p>
-        </p:txBody>
-      </p:sp>
-      <p:sp>
-        <p:nvSpPr>
-          <p:cNvPr id="20" name="TextBox 19"/>
-          <p:cNvSpPr txBox="1"/>
-          <p:nvPr/>
-        </p:nvSpPr>
-        <p:spPr>
-          <a:xfrm>
-            <a:off x="7909560" y="3959352"/>
-            <a:ext cx="3429000" cy="201168"/>
-          </a:xfrm>
-          <a:prstGeom prst="rect">
-            <a:avLst/>
-          </a:prstGeom>
-          <a:noFill/>
-        </p:spPr>
-        <p:txBody>
-          <a:bodyPr wrap="square" anchor="t" lIns="0" rIns="0" tIns="0" bIns="0">
-            <a:noAutofit/>
-          </a:bodyPr>
-          <a:lstStyle/>
-          <a:p>
-            <a:pPr algn="ctr">
-              <a:spcBef>
-                <a:spcPts val="0"/>
-              </a:spcBef>
-              <a:spcAft>
-                <a:spcPts val="200"/>
-              </a:spcAft>
-            </a:pPr>
-            <a:r>
-              <a:rPr sz="1200" b="0" i="0">
-                <a:solidFill>
-                  <a:srgbClr val="5B6B78"/>
-                </a:solidFill>
-                <a:latin typeface="Consolas"/>
-              </a:rPr>
-              <a:t>PostgreSQL wire · pgx</a:t>
-            </a:r>
-          </a:p>
-        </p:txBody>
-      </p:sp>
-      <p:sp>
-        <p:nvSpPr>
-          <p:cNvPr id="21" name="Rounded Rectangle 20"/>
-          <p:cNvSpPr/>
-          <p:nvPr/>
-        </p:nvSpPr>
-        <p:spPr>
-          <a:xfrm>
-            <a:off x="7909560" y="4242816"/>
-            <a:ext cx="3429000" cy="621792"/>
           </a:xfrm>
           <a:prstGeom prst="roundRect">
             <a:avLst>
@@ -20818,20 +20546,208 @@
           </a:ln>
           <a:effectLst/>
         </p:spPr>
-        <p:style>
-          <a:lnRef idx="1">
-            <a:schemeClr val="accent1"/>
-          </a:lnRef>
-          <a:fillRef idx="3">
-            <a:schemeClr val="accent1"/>
-          </a:fillRef>
-          <a:effectRef idx="2">
-            <a:schemeClr val="accent1"/>
-          </a:effectRef>
-          <a:fontRef idx="minor">
-            <a:schemeClr val="lt1"/>
-          </a:fontRef>
-        </p:style>
+        <p:txBody>
+          <a:bodyPr rtlCol="0" anchor="ctr"/>
+          <a:lstStyle/>
+          <a:p>
+            <a:pPr algn="ctr"/>
+          </a:p>
+        </p:txBody>
+      </p:sp>
+      <p:sp>
+        <p:nvSpPr>
+          <p:cNvPr id="17" name="TextBox 16"/>
+          <p:cNvSpPr txBox="1"/>
+          <p:nvPr/>
+        </p:nvSpPr>
+        <p:spPr>
+          <a:xfrm>
+            <a:off x="8092440" y="3191256"/>
+            <a:ext cx="3063240" cy="274320"/>
+          </a:xfrm>
+          <a:prstGeom prst="rect">
+            <a:avLst/>
+          </a:prstGeom>
+          <a:noFill/>
+        </p:spPr>
+        <p:txBody>
+          <a:bodyPr wrap="square" anchor="t" lIns="0" rIns="0" tIns="0" bIns="0">
+            <a:noAutofit/>
+          </a:bodyPr>
+          <a:lstStyle/>
+          <a:p>
+            <a:pPr algn="l">
+              <a:spcBef>
+                <a:spcPts val="0"/>
+              </a:spcBef>
+              <a:spcAft>
+                <a:spcPts val="200"/>
+              </a:spcAft>
+            </a:pPr>
+            <a:r>
+              <a:rPr sz="1400" b="1" i="0">
+                <a:solidFill>
+                  <a:srgbClr val="156082"/>
+                </a:solidFill>
+                <a:latin typeface="Calibri"/>
+              </a:rPr>
+              <a:t>MobilityAPI (Go)</a:t>
+            </a:r>
+          </a:p>
+        </p:txBody>
+      </p:sp>
+      <p:sp>
+        <p:nvSpPr>
+          <p:cNvPr id="18" name="TextBox 17"/>
+          <p:cNvSpPr txBox="1"/>
+          <p:nvPr/>
+        </p:nvSpPr>
+        <p:spPr>
+          <a:xfrm>
+            <a:off x="8092440" y="3456432"/>
+            <a:ext cx="3063240" cy="228600"/>
+          </a:xfrm>
+          <a:prstGeom prst="rect">
+            <a:avLst/>
+          </a:prstGeom>
+          <a:noFill/>
+        </p:spPr>
+        <p:txBody>
+          <a:bodyPr wrap="square" anchor="t" lIns="0" rIns="0" tIns="0" bIns="0">
+            <a:noAutofit/>
+          </a:bodyPr>
+          <a:lstStyle/>
+          <a:p>
+            <a:pPr algn="l">
+              <a:spcBef>
+                <a:spcPts val="0"/>
+              </a:spcBef>
+              <a:spcAft>
+                <a:spcPts val="200"/>
+              </a:spcAft>
+            </a:pPr>
+            <a:r>
+              <a:rPr sz="1200" b="0" i="0">
+                <a:solidFill>
+                  <a:srgbClr val="5B6B78"/>
+                </a:solidFill>
+                <a:latin typeface="Consolas"/>
+              </a:rPr>
+              <a:t>net/http + pgxpool</a:t>
+            </a:r>
+          </a:p>
+        </p:txBody>
+      </p:sp>
+      <p:sp>
+        <p:nvSpPr>
+          <p:cNvPr id="19" name="TextBox 18"/>
+          <p:cNvSpPr txBox="1"/>
+          <p:nvPr/>
+        </p:nvSpPr>
+        <p:spPr>
+          <a:xfrm>
+            <a:off x="7909560" y="3749040"/>
+            <a:ext cx="3429000" cy="219456"/>
+          </a:xfrm>
+          <a:prstGeom prst="rect">
+            <a:avLst/>
+          </a:prstGeom>
+          <a:noFill/>
+        </p:spPr>
+        <p:txBody>
+          <a:bodyPr wrap="square" anchor="t" lIns="0" rIns="0" tIns="0" bIns="0">
+            <a:noAutofit/>
+          </a:bodyPr>
+          <a:lstStyle/>
+          <a:p>
+            <a:pPr algn="ctr">
+              <a:spcBef>
+                <a:spcPts val="0"/>
+              </a:spcBef>
+              <a:spcAft>
+                <a:spcPts val="200"/>
+              </a:spcAft>
+            </a:pPr>
+            <a:r>
+              <a:rPr sz="1200" b="1" i="0">
+                <a:solidFill>
+                  <a:srgbClr val="E97132"/>
+                </a:solidFill>
+                <a:latin typeface="Calibri"/>
+              </a:rPr>
+              <a:t>▼  SQL</a:t>
+            </a:r>
+          </a:p>
+        </p:txBody>
+      </p:sp>
+      <p:sp>
+        <p:nvSpPr>
+          <p:cNvPr id="20" name="TextBox 19"/>
+          <p:cNvSpPr txBox="1"/>
+          <p:nvPr/>
+        </p:nvSpPr>
+        <p:spPr>
+          <a:xfrm>
+            <a:off x="7909560" y="3959352"/>
+            <a:ext cx="3429000" cy="201168"/>
+          </a:xfrm>
+          <a:prstGeom prst="rect">
+            <a:avLst/>
+          </a:prstGeom>
+          <a:noFill/>
+        </p:spPr>
+        <p:txBody>
+          <a:bodyPr wrap="square" anchor="t" lIns="0" rIns="0" tIns="0" bIns="0">
+            <a:noAutofit/>
+          </a:bodyPr>
+          <a:lstStyle/>
+          <a:p>
+            <a:pPr algn="ctr">
+              <a:spcBef>
+                <a:spcPts val="0"/>
+              </a:spcBef>
+              <a:spcAft>
+                <a:spcPts val="200"/>
+              </a:spcAft>
+            </a:pPr>
+            <a:r>
+              <a:rPr sz="1200" b="0" i="0">
+                <a:solidFill>
+                  <a:srgbClr val="5B6B78"/>
+                </a:solidFill>
+                <a:latin typeface="Consolas"/>
+              </a:rPr>
+              <a:t>PostgreSQL wire · pgx</a:t>
+            </a:r>
+          </a:p>
+        </p:txBody>
+      </p:sp>
+      <p:sp>
+        <p:nvSpPr>
+          <p:cNvPr id="21" name="Rounded Rectangle 20"/>
+          <p:cNvSpPr/>
+          <p:nvPr/>
+        </p:nvSpPr>
+        <p:spPr>
+          <a:xfrm>
+            <a:off x="7909560" y="4242816"/>
+            <a:ext cx="3429000" cy="621792"/>
+          </a:xfrm>
+          <a:prstGeom prst="roundRect">
+            <a:avLst>
+              <a:gd name="adj" fmla="val 12000"/>
+            </a:avLst>
+          </a:prstGeom>
+          <a:solidFill>
+            <a:srgbClr val="FFFFFF"/>
+          </a:solidFill>
+          <a:ln w="19050">
+            <a:solidFill>
+              <a:srgbClr val="0E2841"/>
+            </a:solidFill>
+          </a:ln>
+          <a:effectLst/>
+        </p:spPr>
         <p:txBody>
           <a:bodyPr rtlCol="0" anchor="ctr"/>
           <a:lstStyle/>

</xml_diff>

<commit_message>
V5 deck: sentence-case the architecture panel label; drop the self-evident SQL-vs-REST caption
The bottom panel on the architecture slide reads No MEOS in the tier, matching the
sentence-case column sub-headers beside it instead of an all-caps eyebrow. Removes
the SQL-vs-REST caption, whose point is already carried by the slide kicker, title,
and the side-by-side panels.
</commit_message>
<xml_diff>
--- a/MobilityAPIV5.pptx
+++ b/MobilityAPIV5.pptx
@@ -30180,8 +30180,8 @@
         </p:nvSpPr>
         <p:spPr>
           <a:xfrm>
-            <a:off x="841247" y="4700016"/>
-            <a:ext cx="5486400" cy="274320"/>
+            <a:off x="841247" y="4681728"/>
+            <a:ext cx="5486400" cy="320040"/>
           </a:xfrm>
           <a:prstGeom prst="rect">
             <a:avLst/>
@@ -30203,13 +30203,13 @@
               </a:spcAft>
             </a:pPr>
             <a:r>
-              <a:rPr sz="1200" b="1" i="0">
+              <a:rPr sz="1400" b="1" i="0">
                 <a:solidFill>
                   <a:srgbClr val="156082"/>
                 </a:solidFill>
                 <a:latin typeface="Calibri"/>
               </a:rPr>
-              <a:t>NO MEOS IN THE TIER</a:t>
+              <a:t>No MEOS in the tier</a:t>
             </a:r>
           </a:p>
         </p:txBody>
@@ -32037,49 +32037,7 @@
       </p:sp>
       <p:sp>
         <p:nvSpPr>
-          <p:cNvPr id="11" name="TextBox 10"/>
-          <p:cNvSpPr txBox="1"/>
-          <p:nvPr/>
-        </p:nvSpPr>
-        <p:spPr>
-          <a:xfrm>
-            <a:off x="566928" y="5577840"/>
-            <a:ext cx="11057839" cy="365760"/>
-          </a:xfrm>
-          <a:prstGeom prst="rect">
-            <a:avLst/>
-          </a:prstGeom>
-          <a:noFill/>
-        </p:spPr>
-        <p:txBody>
-          <a:bodyPr wrap="square" anchor="t" lIns="0" rIns="0" tIns="0" bIns="0">
-            <a:noAutofit/>
-          </a:bodyPr>
-          <a:lstStyle/>
-          <a:p>
-            <a:pPr algn="ctr">
-              <a:spcBef>
-                <a:spcPts val="0"/>
-              </a:spcBef>
-              <a:spcAft>
-                <a:spcPts val="200"/>
-              </a:spcAft>
-            </a:pPr>
-            <a:r>
-              <a:rPr sz="1200" b="0" i="1">
-                <a:solidFill>
-                  <a:srgbClr val="5B6B78"/>
-                </a:solidFill>
-                <a:latin typeface="Calibri"/>
-              </a:rPr>
-              <a:t>Identical trajectory. The REST client never writes SQL or opens a database connection.</a:t>
-            </a:r>
-          </a:p>
-        </p:txBody>
-      </p:sp>
-      <p:sp>
-        <p:nvSpPr>
-          <p:cNvPr id="12" name="Rectangle 11"/>
+          <p:cNvPr id="11" name="Rectangle 10"/>
           <p:cNvSpPr/>
           <p:nvPr/>
         </p:nvSpPr>
@@ -32123,7 +32081,7 @@
       </p:sp>
       <p:sp>
         <p:nvSpPr>
-          <p:cNvPr id="13" name="TextBox 12"/>
+          <p:cNvPr id="12" name="TextBox 11"/>
           <p:cNvSpPr txBox="1"/>
           <p:nvPr/>
         </p:nvSpPr>
@@ -32165,7 +32123,7 @@
       </p:sp>
       <p:sp>
         <p:nvSpPr>
-          <p:cNvPr id="14" name="TextBox 13"/>
+          <p:cNvPr id="13" name="TextBox 12"/>
           <p:cNvSpPr txBox="1"/>
           <p:nvPr/>
         </p:nvSpPr>

</xml_diff>

<commit_message>
V5 deck: box paragraph notes uniformly; unify endpoint+descriptor spacing via one helper
Adds a notebox helper (panel + label + bullets, matching the No MEOS in the tier
box) and routes the in-content paragraph notes through it: the endpoint-surface
notes, the backing-model provenance note, and the temporal-geometry note. Adds an
ep helper for the method-pill-plus-descriptor row so the descriptor sits below the
pill with one consistent offset everywhere (writes delete, the export and replace
rows), fixing the descriptor/pill overlap globally rather than per instance.
</commit_message>
<xml_diff>
--- a/MobilityAPIV5.pptx
+++ b/MobilityAPIV5.pptx
@@ -5529,7 +5529,7 @@
         </p:nvSpPr>
         <p:spPr>
           <a:xfrm>
-            <a:off x="566928" y="2007107"/>
+            <a:off x="566928" y="1961388"/>
             <a:ext cx="640080" cy="292608"/>
           </a:xfrm>
           <a:prstGeom prst="roundRect">
@@ -5584,7 +5584,7 @@
         </p:nvSpPr>
         <p:spPr>
           <a:xfrm>
-            <a:off x="1353312" y="2002536"/>
+            <a:off x="1353312" y="1956816"/>
             <a:ext cx="10253167" cy="292608"/>
           </a:xfrm>
           <a:prstGeom prst="rect">
@@ -5626,7 +5626,7 @@
         </p:nvSpPr>
         <p:spPr>
           <a:xfrm>
-            <a:off x="566928" y="2418588"/>
+            <a:off x="566928" y="2327148"/>
             <a:ext cx="640080" cy="292608"/>
           </a:xfrm>
           <a:prstGeom prst="roundRect">
@@ -5681,7 +5681,7 @@
         </p:nvSpPr>
         <p:spPr>
           <a:xfrm>
-            <a:off x="1280160" y="2418588"/>
+            <a:off x="1280160" y="2327148"/>
             <a:ext cx="713232" cy="292608"/>
           </a:xfrm>
           <a:prstGeom prst="roundRect">
@@ -5736,7 +5736,7 @@
         </p:nvSpPr>
         <p:spPr>
           <a:xfrm>
-            <a:off x="2139696" y="2414016"/>
+            <a:off x="2139696" y="2322576"/>
             <a:ext cx="9466783" cy="292608"/>
           </a:xfrm>
           <a:prstGeom prst="rect">
@@ -5778,7 +5778,7 @@
         </p:nvSpPr>
         <p:spPr>
           <a:xfrm>
-            <a:off x="566928" y="2830068"/>
+            <a:off x="566928" y="2692908"/>
             <a:ext cx="640080" cy="292608"/>
           </a:xfrm>
           <a:prstGeom prst="roundRect">
@@ -5833,7 +5833,7 @@
         </p:nvSpPr>
         <p:spPr>
           <a:xfrm>
-            <a:off x="1280160" y="2830068"/>
+            <a:off x="1280160" y="2692908"/>
             <a:ext cx="932688" cy="292608"/>
           </a:xfrm>
           <a:prstGeom prst="roundRect">
@@ -5888,7 +5888,7 @@
         </p:nvSpPr>
         <p:spPr>
           <a:xfrm>
-            <a:off x="2359152" y="2825496"/>
+            <a:off x="2359152" y="2688336"/>
             <a:ext cx="9247327" cy="292608"/>
           </a:xfrm>
           <a:prstGeom prst="rect">
@@ -5930,7 +5930,7 @@
         </p:nvSpPr>
         <p:spPr>
           <a:xfrm>
-            <a:off x="566928" y="3241548"/>
+            <a:off x="566928" y="3058668"/>
             <a:ext cx="640080" cy="292608"/>
           </a:xfrm>
           <a:prstGeom prst="roundRect">
@@ -5985,7 +5985,7 @@
         </p:nvSpPr>
         <p:spPr>
           <a:xfrm>
-            <a:off x="1280160" y="3241548"/>
+            <a:off x="1280160" y="3058668"/>
             <a:ext cx="713232" cy="292608"/>
           </a:xfrm>
           <a:prstGeom prst="roundRect">
@@ -6040,7 +6040,7 @@
         </p:nvSpPr>
         <p:spPr>
           <a:xfrm>
-            <a:off x="2139696" y="3236976"/>
+            <a:off x="2139696" y="3054096"/>
             <a:ext cx="9466783" cy="292608"/>
           </a:xfrm>
           <a:prstGeom prst="rect">
@@ -6082,7 +6082,7 @@
         </p:nvSpPr>
         <p:spPr>
           <a:xfrm>
-            <a:off x="566928" y="3653028"/>
+            <a:off x="566928" y="3424427"/>
             <a:ext cx="640080" cy="292608"/>
           </a:xfrm>
           <a:prstGeom prst="roundRect">
@@ -6137,7 +6137,7 @@
         </p:nvSpPr>
         <p:spPr>
           <a:xfrm>
-            <a:off x="1353312" y="3648456"/>
+            <a:off x="1353312" y="3419856"/>
             <a:ext cx="10253167" cy="292608"/>
           </a:xfrm>
           <a:prstGeom prst="rect">
@@ -6179,7 +6179,7 @@
         </p:nvSpPr>
         <p:spPr>
           <a:xfrm>
-            <a:off x="566928" y="4064508"/>
+            <a:off x="566928" y="3790187"/>
             <a:ext cx="640080" cy="292608"/>
           </a:xfrm>
           <a:prstGeom prst="roundRect">
@@ -6234,7 +6234,7 @@
         </p:nvSpPr>
         <p:spPr>
           <a:xfrm>
-            <a:off x="1353312" y="4059936"/>
+            <a:off x="1353312" y="3785615"/>
             <a:ext cx="10253167" cy="292608"/>
           </a:xfrm>
           <a:prstGeom prst="rect">
@@ -6276,7 +6276,7 @@
         </p:nvSpPr>
         <p:spPr>
           <a:xfrm>
-            <a:off x="566928" y="4475988"/>
+            <a:off x="566928" y="4155948"/>
             <a:ext cx="640080" cy="292608"/>
           </a:xfrm>
           <a:prstGeom prst="roundRect">
@@ -6331,7 +6331,7 @@
         </p:nvSpPr>
         <p:spPr>
           <a:xfrm>
-            <a:off x="1353312" y="4471416"/>
+            <a:off x="1353312" y="4151376"/>
             <a:ext cx="10253167" cy="292608"/>
           </a:xfrm>
           <a:prstGeom prst="rect">
@@ -6373,7 +6373,7 @@
         </p:nvSpPr>
         <p:spPr>
           <a:xfrm>
-            <a:off x="566928" y="4887468"/>
+            <a:off x="566928" y="4521708"/>
             <a:ext cx="640080" cy="292608"/>
           </a:xfrm>
           <a:prstGeom prst="roundRect">
@@ -6428,7 +6428,7 @@
         </p:nvSpPr>
         <p:spPr>
           <a:xfrm>
-            <a:off x="1353312" y="4882896"/>
+            <a:off x="1353312" y="4517136"/>
             <a:ext cx="10253167" cy="292608"/>
           </a:xfrm>
           <a:prstGeom prst="rect">
@@ -6470,7 +6470,7 @@
         </p:nvSpPr>
         <p:spPr>
           <a:xfrm>
-            <a:off x="566928" y="5298948"/>
+            <a:off x="566928" y="4887468"/>
             <a:ext cx="640080" cy="292608"/>
           </a:xfrm>
           <a:prstGeom prst="roundRect">
@@ -6525,7 +6525,7 @@
         </p:nvSpPr>
         <p:spPr>
           <a:xfrm>
-            <a:off x="1353312" y="5294376"/>
+            <a:off x="1353312" y="4882896"/>
             <a:ext cx="10253167" cy="292608"/>
           </a:xfrm>
           <a:prstGeom prst="rect">
@@ -6561,14 +6561,46 @@
       </p:sp>
       <p:sp>
         <p:nvSpPr>
-          <p:cNvPr id="29" name="TextBox 28"/>
+          <p:cNvPr id="29" name="Rounded Rectangle 28"/>
+          <p:cNvSpPr/>
+          <p:nvPr/>
+        </p:nvSpPr>
+        <p:spPr>
+          <a:xfrm>
+            <a:off x="566928" y="5358384"/>
+            <a:ext cx="11057839" cy="969264"/>
+          </a:xfrm>
+          <a:prstGeom prst="roundRect">
+            <a:avLst>
+              <a:gd name="adj" fmla="val 4000"/>
+            </a:avLst>
+          </a:prstGeom>
+          <a:solidFill>
+            <a:srgbClr val="F1F5F8"/>
+          </a:solidFill>
+          <a:ln>
+            <a:noFill/>
+          </a:ln>
+          <a:effectLst/>
+        </p:spPr>
+        <p:txBody>
+          <a:bodyPr rtlCol="0" anchor="ctr"/>
+          <a:lstStyle/>
+          <a:p>
+            <a:pPr algn="ctr"/>
+          </a:p>
+        </p:txBody>
+      </p:sp>
+      <p:sp>
+        <p:nvSpPr>
+          <p:cNvPr id="30" name="TextBox 29"/>
           <p:cNvSpPr txBox="1"/>
           <p:nvPr/>
         </p:nvSpPr>
         <p:spPr>
           <a:xfrm>
-            <a:off x="566928" y="5833872"/>
-            <a:ext cx="11057839" cy="640080"/>
+            <a:off x="822960" y="5449824"/>
+            <a:ext cx="10545775" cy="274320"/>
           </a:xfrm>
           <a:prstGeom prst="rect">
             <a:avLst/>
@@ -6590,20 +6622,105 @@
               </a:spcAft>
             </a:pPr>
             <a:r>
-              <a:rPr sz="1200" b="0" i="1">
-                <a:solidFill>
-                  <a:srgbClr val="5B6B78"/>
-                </a:solidFill>
-                <a:latin typeface="Calibri"/>
-              </a:rPr>
-              <a:t>Every path above is OGC API – Moving Features – Part 1: Core. acceleration is offered at the same path but returns 501 (not derivable for this motion model). Items query parameters: bbox, datetime, subtrajectory, leaf, limit, page cursor.</a:t>
-            </a:r>
-          </a:p>
-        </p:txBody>
-      </p:sp>
-      <p:sp>
-        <p:nvSpPr>
-          <p:cNvPr id="30" name="Rectangle 29"/>
+              <a:rPr sz="1200" b="1" i="0">
+                <a:solidFill>
+                  <a:srgbClr val="156082"/>
+                </a:solidFill>
+                <a:latin typeface="Calibri"/>
+              </a:rPr>
+              <a:t>Notes</a:t>
+            </a:r>
+          </a:p>
+        </p:txBody>
+      </p:sp>
+      <p:sp>
+        <p:nvSpPr>
+          <p:cNvPr id="31" name="TextBox 30"/>
+          <p:cNvSpPr txBox="1"/>
+          <p:nvPr/>
+        </p:nvSpPr>
+        <p:spPr>
+          <a:xfrm>
+            <a:off x="822960" y="5742432"/>
+            <a:ext cx="10545775" cy="530352"/>
+          </a:xfrm>
+          <a:prstGeom prst="rect">
+            <a:avLst/>
+          </a:prstGeom>
+          <a:noFill/>
+        </p:spPr>
+        <p:txBody>
+          <a:bodyPr wrap="square" lIns="0" rIns="0" tIns="0" bIns="0">
+            <a:noAutofit/>
+          </a:bodyPr>
+          <a:lstStyle/>
+          <a:p>
+            <a:pPr>
+              <a:lnSpc>
+                <a:spcPct val="106000"/>
+              </a:lnSpc>
+              <a:spcBef>
+                <a:spcPts val="0"/>
+              </a:spcBef>
+              <a:spcAft>
+                <a:spcPts val="300"/>
+              </a:spcAft>
+            </a:pPr>
+            <a:r>
+              <a:rPr sz="1200" b="1">
+                <a:solidFill>
+                  <a:srgbClr val="156082"/>
+                </a:solidFill>
+                <a:latin typeface="Calibri"/>
+              </a:rPr>
+              <a:t>▸  </a:t>
+            </a:r>
+            <a:r>
+              <a:rPr sz="1200">
+                <a:solidFill>
+                  <a:srgbClr val="1E2B36"/>
+                </a:solidFill>
+                <a:latin typeface="Calibri"/>
+              </a:rPr>
+              <a:t>Every path above is OGC API – Moving Features – Part 1: Core; acceleration returns 501 (not derivable)</a:t>
+            </a:r>
+          </a:p>
+          <a:p>
+            <a:pPr>
+              <a:lnSpc>
+                <a:spcPct val="106000"/>
+              </a:lnSpc>
+              <a:spcBef>
+                <a:spcPts val="0"/>
+              </a:spcBef>
+              <a:spcAft>
+                <a:spcPts val="300"/>
+              </a:spcAft>
+            </a:pPr>
+            <a:r>
+              <a:rPr sz="1200" b="1">
+                <a:solidFill>
+                  <a:srgbClr val="156082"/>
+                </a:solidFill>
+                <a:latin typeface="Calibri"/>
+              </a:rPr>
+              <a:t>▸  </a:t>
+            </a:r>
+            <a:r>
+              <a:rPr sz="1200">
+                <a:solidFill>
+                  <a:srgbClr val="1E2B36"/>
+                </a:solidFill>
+                <a:latin typeface="Calibri"/>
+              </a:rPr>
+              <a:t>Items query parameters: bbox, datetime, subtrajectory, leaf, limit, page cursor</a:t>
+            </a:r>
+          </a:p>
+        </p:txBody>
+      </p:sp>
+      <p:sp>
+        <p:nvSpPr>
+          <p:cNvPr id="32" name="Rectangle 31"/>
           <p:cNvSpPr/>
           <p:nvPr/>
         </p:nvSpPr>
@@ -6647,7 +6764,7 @@
       </p:sp>
       <p:sp>
         <p:nvSpPr>
-          <p:cNvPr id="31" name="TextBox 30"/>
+          <p:cNvPr id="33" name="TextBox 32"/>
           <p:cNvSpPr txBox="1"/>
           <p:nvPr/>
         </p:nvSpPr>
@@ -6689,7 +6806,7 @@
       </p:sp>
       <p:sp>
         <p:nvSpPr>
-          <p:cNvPr id="32" name="TextBox 31"/>
+          <p:cNvPr id="34" name="TextBox 33"/>
           <p:cNvSpPr txBox="1"/>
           <p:nvPr/>
         </p:nvSpPr>
@@ -16546,7 +16663,7 @@
         </p:nvSpPr>
         <p:spPr>
           <a:xfrm>
-            <a:off x="6281928" y="1801368"/>
+            <a:off x="6281928" y="1783080"/>
             <a:ext cx="932688" cy="292608"/>
           </a:xfrm>
           <a:prstGeom prst="roundRect">
@@ -16601,8 +16718,8 @@
         </p:nvSpPr>
         <p:spPr>
           <a:xfrm>
-            <a:off x="7306056" y="1783080"/>
-            <a:ext cx="4318711" cy="274320"/>
+            <a:off x="7324344" y="1773936"/>
+            <a:ext cx="4300423" cy="274320"/>
           </a:xfrm>
           <a:prstGeom prst="rect">
             <a:avLst/>
@@ -16643,7 +16760,7 @@
         </p:nvSpPr>
         <p:spPr>
           <a:xfrm>
-            <a:off x="6281928" y="2075688"/>
+            <a:off x="6281928" y="2130552"/>
             <a:ext cx="5342839" cy="274320"/>
           </a:xfrm>
           <a:prstGeom prst="rect">
@@ -18079,14 +18196,46 @@
       </p:sp>
       <p:sp>
         <p:nvSpPr>
-          <p:cNvPr id="11" name="TextBox 10"/>
+          <p:cNvPr id="11" name="Rounded Rectangle 10"/>
+          <p:cNvSpPr/>
+          <p:nvPr/>
+        </p:nvSpPr>
+        <p:spPr>
+          <a:xfrm>
+            <a:off x="6281928" y="4160520"/>
+            <a:ext cx="5342839" cy="969264"/>
+          </a:xfrm>
+          <a:prstGeom prst="roundRect">
+            <a:avLst>
+              <a:gd name="adj" fmla="val 4000"/>
+            </a:avLst>
+          </a:prstGeom>
+          <a:solidFill>
+            <a:srgbClr val="F1F5F8"/>
+          </a:solidFill>
+          <a:ln>
+            <a:noFill/>
+          </a:ln>
+          <a:effectLst/>
+        </p:spPr>
+        <p:txBody>
+          <a:bodyPr rtlCol="0" anchor="ctr"/>
+          <a:lstStyle/>
+          <a:p>
+            <a:pPr algn="ctr"/>
+          </a:p>
+        </p:txBody>
+      </p:sp>
+      <p:sp>
+        <p:nvSpPr>
+          <p:cNvPr id="12" name="TextBox 11"/>
           <p:cNvSpPr txBox="1"/>
           <p:nvPr/>
         </p:nvSpPr>
         <p:spPr>
           <a:xfrm>
-            <a:off x="6281928" y="4206240"/>
-            <a:ext cx="5342839" cy="914400"/>
+            <a:off x="6537960" y="4251959"/>
+            <a:ext cx="4830775" cy="274320"/>
           </a:xfrm>
           <a:prstGeom prst="rect">
             <a:avLst/>
@@ -18108,20 +18257,105 @@
               </a:spcAft>
             </a:pPr>
             <a:r>
-              <a:rPr sz="1200" b="0" i="1">
-                <a:solidFill>
-                  <a:srgbClr val="5B6B78"/>
-                </a:solidFill>
-                <a:latin typeface="Calibri"/>
-              </a:rPr>
-              <a:t>The temporal geometry is the trajectory itself, returned as MovingFeaturesJSON straight from asMFJSON.</a:t>
-            </a:r>
-          </a:p>
-        </p:txBody>
-      </p:sp>
-      <p:sp>
-        <p:nvSpPr>
-          <p:cNvPr id="12" name="Rectangle 11"/>
+              <a:rPr sz="1200" b="1" i="0">
+                <a:solidFill>
+                  <a:srgbClr val="156082"/>
+                </a:solidFill>
+                <a:latin typeface="Calibri"/>
+              </a:rPr>
+              <a:t>Temporal geometry</a:t>
+            </a:r>
+          </a:p>
+        </p:txBody>
+      </p:sp>
+      <p:sp>
+        <p:nvSpPr>
+          <p:cNvPr id="13" name="TextBox 12"/>
+          <p:cNvSpPr txBox="1"/>
+          <p:nvPr/>
+        </p:nvSpPr>
+        <p:spPr>
+          <a:xfrm>
+            <a:off x="6537960" y="4544568"/>
+            <a:ext cx="4830775" cy="530352"/>
+          </a:xfrm>
+          <a:prstGeom prst="rect">
+            <a:avLst/>
+          </a:prstGeom>
+          <a:noFill/>
+        </p:spPr>
+        <p:txBody>
+          <a:bodyPr wrap="square" lIns="0" rIns="0" tIns="0" bIns="0">
+            <a:noAutofit/>
+          </a:bodyPr>
+          <a:lstStyle/>
+          <a:p>
+            <a:pPr>
+              <a:lnSpc>
+                <a:spcPct val="106000"/>
+              </a:lnSpc>
+              <a:spcBef>
+                <a:spcPts val="0"/>
+              </a:spcBef>
+              <a:spcAft>
+                <a:spcPts val="300"/>
+              </a:spcAft>
+            </a:pPr>
+            <a:r>
+              <a:rPr sz="1200" b="1">
+                <a:solidFill>
+                  <a:srgbClr val="156082"/>
+                </a:solidFill>
+                <a:latin typeface="Calibri"/>
+              </a:rPr>
+              <a:t>▸  </a:t>
+            </a:r>
+            <a:r>
+              <a:rPr sz="1200">
+                <a:solidFill>
+                  <a:srgbClr val="1E2B36"/>
+                </a:solidFill>
+                <a:latin typeface="Calibri"/>
+              </a:rPr>
+              <a:t>The temporal geometry is the trajectory itself</a:t>
+            </a:r>
+          </a:p>
+          <a:p>
+            <a:pPr>
+              <a:lnSpc>
+                <a:spcPct val="106000"/>
+              </a:lnSpc>
+              <a:spcBef>
+                <a:spcPts val="0"/>
+              </a:spcBef>
+              <a:spcAft>
+                <a:spcPts val="300"/>
+              </a:spcAft>
+            </a:pPr>
+            <a:r>
+              <a:rPr sz="1200" b="1">
+                <a:solidFill>
+                  <a:srgbClr val="156082"/>
+                </a:solidFill>
+                <a:latin typeface="Calibri"/>
+              </a:rPr>
+              <a:t>▸  </a:t>
+            </a:r>
+            <a:r>
+              <a:rPr sz="1200">
+                <a:solidFill>
+                  <a:srgbClr val="1E2B36"/>
+                </a:solidFill>
+                <a:latin typeface="Calibri"/>
+              </a:rPr>
+              <a:t>Returned as MovingFeaturesJSON by asMFJSON</a:t>
+            </a:r>
+          </a:p>
+        </p:txBody>
+      </p:sp>
+      <p:sp>
+        <p:nvSpPr>
+          <p:cNvPr id="14" name="Rectangle 13"/>
           <p:cNvSpPr/>
           <p:nvPr/>
         </p:nvSpPr>
@@ -18165,7 +18399,7 @@
       </p:sp>
       <p:sp>
         <p:nvSpPr>
-          <p:cNvPr id="13" name="TextBox 12"/>
+          <p:cNvPr id="15" name="TextBox 14"/>
           <p:cNvSpPr txBox="1"/>
           <p:nvPr/>
         </p:nvSpPr>
@@ -18207,7 +18441,7 @@
       </p:sp>
       <p:sp>
         <p:nvSpPr>
-          <p:cNvPr id="14" name="TextBox 13"/>
+          <p:cNvPr id="16" name="TextBox 15"/>
           <p:cNvSpPr txBox="1"/>
           <p:nvPr/>
         </p:nvSpPr>
@@ -24804,7 +25038,7 @@
         </p:nvSpPr>
         <p:spPr>
           <a:xfrm>
-            <a:off x="4453128" y="4361688"/>
+            <a:off x="4453128" y="4389120"/>
             <a:ext cx="7171639" cy="274320"/>
           </a:xfrm>
           <a:prstGeom prst="rect">
@@ -24943,7 +25177,7 @@
         </p:nvSpPr>
         <p:spPr>
           <a:xfrm>
-            <a:off x="4453128" y="5056632"/>
+            <a:off x="4453128" y="5084064"/>
             <a:ext cx="7171639" cy="274320"/>
           </a:xfrm>
           <a:prstGeom prst="rect">
@@ -34693,14 +34927,46 @@
       </p:sp>
       <p:sp>
         <p:nvSpPr>
-          <p:cNvPr id="20" name="TextBox 19"/>
+          <p:cNvPr id="20" name="Rounded Rectangle 19"/>
+          <p:cNvSpPr/>
+          <p:nvPr/>
+        </p:nvSpPr>
+        <p:spPr>
+          <a:xfrm>
+            <a:off x="5138928" y="5376672"/>
+            <a:ext cx="6485839" cy="969264"/>
+          </a:xfrm>
+          <a:prstGeom prst="roundRect">
+            <a:avLst>
+              <a:gd name="adj" fmla="val 4000"/>
+            </a:avLst>
+          </a:prstGeom>
+          <a:solidFill>
+            <a:srgbClr val="F1F5F8"/>
+          </a:solidFill>
+          <a:ln>
+            <a:noFill/>
+          </a:ln>
+          <a:effectLst/>
+        </p:spPr>
+        <p:txBody>
+          <a:bodyPr rtlCol="0" anchor="ctr"/>
+          <a:lstStyle/>
+          <a:p>
+            <a:pPr algn="ctr"/>
+          </a:p>
+        </p:txBody>
+      </p:sp>
+      <p:sp>
+        <p:nvSpPr>
+          <p:cNvPr id="21" name="TextBox 20"/>
           <p:cNvSpPr txBox="1"/>
           <p:nvPr/>
         </p:nvSpPr>
         <p:spPr>
           <a:xfrm>
-            <a:off x="5138928" y="5669280"/>
-            <a:ext cx="6485839" cy="457200"/>
+            <a:off x="5394960" y="5468112"/>
+            <a:ext cx="5973775" cy="274320"/>
           </a:xfrm>
           <a:prstGeom prst="rect">
             <a:avLst/>
@@ -34722,20 +34988,105 @@
               </a:spcAft>
             </a:pPr>
             <a:r>
-              <a:rPr sz="1200" b="0" i="1">
-                <a:solidFill>
-                  <a:srgbClr val="5B6B78"/>
-                </a:solidFill>
-                <a:latin typeface="Calibri"/>
-              </a:rPr>
-              <a:t>Derived fields come O(1) from the tgeompoint and its inline STBOX; links are generated per request.</a:t>
-            </a:r>
-          </a:p>
-        </p:txBody>
-      </p:sp>
-      <p:sp>
-        <p:nvSpPr>
-          <p:cNvPr id="21" name="Rectangle 20"/>
+              <a:rPr sz="1200" b="1" i="0">
+                <a:solidFill>
+                  <a:srgbClr val="156082"/>
+                </a:solidFill>
+                <a:latin typeface="Calibri"/>
+              </a:rPr>
+              <a:t>How fields are provided</a:t>
+            </a:r>
+          </a:p>
+        </p:txBody>
+      </p:sp>
+      <p:sp>
+        <p:nvSpPr>
+          <p:cNvPr id="22" name="TextBox 21"/>
+          <p:cNvSpPr txBox="1"/>
+          <p:nvPr/>
+        </p:nvSpPr>
+        <p:spPr>
+          <a:xfrm>
+            <a:off x="5394960" y="5760720"/>
+            <a:ext cx="5973775" cy="530352"/>
+          </a:xfrm>
+          <a:prstGeom prst="rect">
+            <a:avLst/>
+          </a:prstGeom>
+          <a:noFill/>
+        </p:spPr>
+        <p:txBody>
+          <a:bodyPr wrap="square" lIns="0" rIns="0" tIns="0" bIns="0">
+            <a:noAutofit/>
+          </a:bodyPr>
+          <a:lstStyle/>
+          <a:p>
+            <a:pPr>
+              <a:lnSpc>
+                <a:spcPct val="106000"/>
+              </a:lnSpc>
+              <a:spcBef>
+                <a:spcPts val="0"/>
+              </a:spcBef>
+              <a:spcAft>
+                <a:spcPts val="300"/>
+              </a:spcAft>
+            </a:pPr>
+            <a:r>
+              <a:rPr sz="1200" b="1">
+                <a:solidFill>
+                  <a:srgbClr val="156082"/>
+                </a:solidFill>
+                <a:latin typeface="Calibri"/>
+              </a:rPr>
+              <a:t>▸  </a:t>
+            </a:r>
+            <a:r>
+              <a:rPr sz="1200">
+                <a:solidFill>
+                  <a:srgbClr val="1E2B36"/>
+                </a:solidFill>
+                <a:latin typeface="Calibri"/>
+              </a:rPr>
+              <a:t>Derived fields come O(1) from the tgeompoint and its inline STBOX</a:t>
+            </a:r>
+          </a:p>
+          <a:p>
+            <a:pPr>
+              <a:lnSpc>
+                <a:spcPct val="106000"/>
+              </a:lnSpc>
+              <a:spcBef>
+                <a:spcPts val="0"/>
+              </a:spcBef>
+              <a:spcAft>
+                <a:spcPts val="300"/>
+              </a:spcAft>
+            </a:pPr>
+            <a:r>
+              <a:rPr sz="1200" b="1">
+                <a:solidFill>
+                  <a:srgbClr val="156082"/>
+                </a:solidFill>
+                <a:latin typeface="Calibri"/>
+              </a:rPr>
+              <a:t>▸  </a:t>
+            </a:r>
+            <a:r>
+              <a:rPr sz="1200">
+                <a:solidFill>
+                  <a:srgbClr val="1E2B36"/>
+                </a:solidFill>
+                <a:latin typeface="Calibri"/>
+              </a:rPr>
+              <a:t>Links are generated per request</a:t>
+            </a:r>
+          </a:p>
+        </p:txBody>
+      </p:sp>
+      <p:sp>
+        <p:nvSpPr>
+          <p:cNvPr id="23" name="Rectangle 22"/>
           <p:cNvSpPr/>
           <p:nvPr/>
         </p:nvSpPr>
@@ -34779,7 +35130,7 @@
       </p:sp>
       <p:sp>
         <p:nvSpPr>
-          <p:cNvPr id="22" name="TextBox 21"/>
+          <p:cNvPr id="24" name="TextBox 23"/>
           <p:cNvSpPr txBox="1"/>
           <p:nvPr/>
         </p:nvSpPr>
@@ -34821,7 +35172,7 @@
       </p:sp>
       <p:sp>
         <p:nvSpPr>
-          <p:cNvPr id="23" name="TextBox 22"/>
+          <p:cNvPr id="25" name="TextBox 24"/>
           <p:cNvSpPr txBox="1"/>
           <p:nvPr/>
         </p:nvSpPr>

</xml_diff>